<commit_message>
deck: split provenance table, add LM eager prediction mechanism and project workflow slides
Adds the LM eager prediction feature to the provenance table (split into two
slides now that it no longer fits one) and a dedicated slide walking through
its masked-LM scoring, entropy gate, and honestly-reported net-neutral
ablation result. Also adds a workflow slide showing the generate-idea /
test / commit cycle the commit log actually follows.

Co-Authored-By: Claude Sonnet 5 <noreply@anthropic.com>
Claude-Session: https://claude.ai/code/session_01EoboXjGNsZRBvVVFDckija
</commit_message>
<xml_diff>
--- a/dist/techjam_track4.pptx
+++ b/dist/techjam_track4.pptx
@@ -27,6 +27,9 @@
     <p:sldId id="275" r:id="rId26"/>
     <p:sldId id="276" r:id="rId27"/>
     <p:sldId id="277" r:id="rId28"/>
+    <p:sldId id="278" r:id="rId29"/>
+    <p:sldId id="279" r:id="rId30"/>
+    <p:sldId id="280" r:id="rId31"/>
   </p:sldIdLst>
   <p:sldSz cx="12191695" cy="6858000" type="screen4x3"/>
   <p:notesSz cx="6858000" cy="9144000"/>
@@ -3600,6 +3603,1458 @@
                 </a:solidFill>
                 <a:latin typeface="Verdana"/>
               </a:rPr>
+              <a:t>PROVENANCE, 2 OF 2</a:t>
+            </a:r>
+          </a:p>
+        </p:txBody>
+      </p:sp>
+      <p:sp>
+        <p:nvSpPr>
+          <p:cNvPr id="3" name="TextBox 2"/>
+          <p:cNvSpPr txBox="1"/>
+          <p:nvPr/>
+        </p:nvSpPr>
+        <p:spPr>
+          <a:xfrm>
+            <a:off x="640080" y="658368"/>
+            <a:ext cx="10881360" cy="685800"/>
+          </a:xfrm>
+          <a:prstGeom prst="rect">
+            <a:avLst/>
+          </a:prstGeom>
+          <a:noFill/>
+        </p:spPr>
+        <p:txBody>
+          <a:bodyPr wrap="square" lIns="0" rIns="0" tIns="0" bIns="0">
+            <a:spAutoFit/>
+          </a:bodyPr>
+          <a:lstStyle/>
+          <a:p>
+            <a:r>
+              <a:rPr sz="2800" b="1">
+                <a:solidFill>
+                  <a:srgbClr val="141B2D"/>
+                </a:solidFill>
+                <a:latin typeface="Georgia"/>
+              </a:rPr>
+              <a:t>What is ours</a:t>
+            </a:r>
+          </a:p>
+        </p:txBody>
+      </p:sp>
+      <p:sp>
+        <p:nvSpPr>
+          <p:cNvPr id="4" name="Rectangle 3"/>
+          <p:cNvSpPr/>
+          <p:nvPr/>
+        </p:nvSpPr>
+        <p:spPr>
+          <a:xfrm>
+            <a:off x="640080" y="1389888"/>
+            <a:ext cx="10908792" cy="9525"/>
+          </a:xfrm>
+          <a:prstGeom prst="rect">
+            <a:avLst/>
+          </a:prstGeom>
+          <a:solidFill>
+            <a:srgbClr val="D8DDE6"/>
+          </a:solidFill>
+          <a:ln>
+            <a:noFill/>
+          </a:ln>
+          <a:effectLst/>
+        </p:spPr>
+        <p:style>
+          <a:lnRef idx="1">
+            <a:schemeClr val="accent1"/>
+          </a:lnRef>
+          <a:fillRef idx="3">
+            <a:schemeClr val="accent1"/>
+          </a:fillRef>
+          <a:effectRef idx="2">
+            <a:schemeClr val="accent1"/>
+          </a:effectRef>
+          <a:fontRef idx="minor">
+            <a:schemeClr val="lt1"/>
+          </a:fontRef>
+        </p:style>
+        <p:txBody>
+          <a:bodyPr rtlCol="0" anchor="ctr"/>
+          <a:lstStyle/>
+          <a:p>
+            <a:pPr algn="ctr"/>
+          </a:p>
+        </p:txBody>
+      </p:sp>
+      <p:graphicFrame>
+        <p:nvGraphicFramePr>
+          <p:cNvPr id="5" name="Table 4"/>
+          <p:cNvGraphicFramePr>
+            <a:graphicFrameLocks noGrp="1"/>
+          </p:cNvGraphicFramePr>
+          <p:nvPr/>
+        </p:nvGraphicFramePr>
+        <p:xfrm>
+          <a:off x="640080" y="1691640"/>
+          <a:ext cx="10908789" cy="2660904"/>
+        </p:xfrm>
+        <a:graphic>
+          <a:graphicData uri="http://schemas.openxmlformats.org/drawingml/2006/table">
+            <a:tbl>
+              <a:tblPr firstRow="1">
+                <a:tableStyleId>{5C22544A-7EE6-4342-B048-85BDC9FD1C3A}</a:tableStyleId>
+              </a:tblPr>
+              <a:tblGrid>
+                <a:gridCol w="2108421"/>
+                <a:gridCol w="3116797"/>
+                <a:gridCol w="4491855"/>
+                <a:gridCol w="1191716"/>
+              </a:tblGrid>
+              <a:tr h="329184">
+                <a:tc>
+                  <a:txBody>
+                    <a:bodyPr/>
+                    <a:lstStyle/>
+                    <a:p>
+                      <a:r>
+                        <a:rPr sz="1100" b="1">
+                          <a:solidFill>
+                            <a:srgbClr val="FFFFFF"/>
+                          </a:solidFill>
+                          <a:latin typeface="Verdana"/>
+                        </a:rPr>
+                        <a:t>Component</a:t>
+                      </a:r>
+                    </a:p>
+                  </a:txBody>
+                  <a:tcPr marL="82296" marR="82296" marT="36576" marB="36576" anchor="ctr">
+                    <a:solidFill>
+                      <a:srgbClr val="141B2D"/>
+                    </a:solidFill>
+                  </a:tcPr>
+                </a:tc>
+                <a:tc>
+                  <a:txBody>
+                    <a:bodyPr/>
+                    <a:lstStyle/>
+                    <a:p>
+                      <a:r>
+                        <a:rPr sz="1100" b="1">
+                          <a:solidFill>
+                            <a:srgbClr val="FFFFFF"/>
+                          </a:solidFill>
+                          <a:latin typeface="Verdana"/>
+                        </a:rPr>
+                        <a:t>Where it comes from</a:t>
+                      </a:r>
+                    </a:p>
+                  </a:txBody>
+                  <a:tcPr marL="82296" marR="82296" marT="36576" marB="36576" anchor="ctr">
+                    <a:solidFill>
+                      <a:srgbClr val="141B2D"/>
+                    </a:solidFill>
+                  </a:tcPr>
+                </a:tc>
+                <a:tc>
+                  <a:txBody>
+                    <a:bodyPr/>
+                    <a:lstStyle/>
+                    <a:p>
+                      <a:r>
+                        <a:rPr sz="1100" b="1">
+                          <a:solidFill>
+                            <a:srgbClr val="FFFFFF"/>
+                          </a:solidFill>
+                          <a:latin typeface="Verdana"/>
+                        </a:rPr>
+                        <a:t>What we did with it</a:t>
+                      </a:r>
+                    </a:p>
+                  </a:txBody>
+                  <a:tcPr marL="82296" marR="82296" marT="36576" marB="36576" anchor="ctr">
+                    <a:solidFill>
+                      <a:srgbClr val="141B2D"/>
+                    </a:solidFill>
+                  </a:tcPr>
+                </a:tc>
+                <a:tc>
+                  <a:txBody>
+                    <a:bodyPr/>
+                    <a:lstStyle/>
+                    <a:p>
+                      <a:r>
+                        <a:rPr sz="1100" b="1">
+                          <a:solidFill>
+                            <a:srgbClr val="FFFFFF"/>
+                          </a:solidFill>
+                          <a:latin typeface="Verdana"/>
+                        </a:rPr>
+                        <a:t/>
+                      </a:r>
+                    </a:p>
+                  </a:txBody>
+                  <a:tcPr marL="82296" marR="82296" marT="36576" marB="36576" anchor="ctr">
+                    <a:solidFill>
+                      <a:srgbClr val="141B2D"/>
+                    </a:solidFill>
+                  </a:tcPr>
+                </a:tc>
+              </a:tr>
+              <a:tr h="777240">
+                <a:tc>
+                  <a:txBody>
+                    <a:bodyPr wrap="square"/>
+                    <a:lstStyle/>
+                    <a:p>
+                      <a:r>
+                        <a:rPr sz="1100" b="0">
+                          <a:solidFill>
+                            <a:srgbClr val="141B2D"/>
+                          </a:solidFill>
+                          <a:latin typeface="Verdana"/>
+                        </a:rPr>
+                        <a:t>Popularity prior</a:t>
+                      </a:r>
+                    </a:p>
+                  </a:txBody>
+                  <a:tcPr marL="82296" marR="82296" marT="36576" marB="36576" anchor="ctr">
+                    <a:solidFill>
+                      <a:srgbClr val="FFFFFF"/>
+                    </a:solidFill>
+                  </a:tcPr>
+                </a:tc>
+                <a:tc>
+                  <a:txBody>
+                    <a:bodyPr wrap="square"/>
+                    <a:lstStyle/>
+                    <a:p>
+                      <a:r>
+                        <a:rPr sz="1100" b="0">
+                          <a:solidFill>
+                            <a:srgbClr val="141B2D"/>
+                          </a:solidFill>
+                          <a:latin typeface="Verdana"/>
+                        </a:rPr>
+                        <a:t>Popularity bias is a known recsys hazard — Abdollahpouri et al., RecSys 2017</a:t>
+                      </a:r>
+                    </a:p>
+                  </a:txBody>
+                  <a:tcPr marL="82296" marR="82296" marT="36576" marB="36576" anchor="ctr">
+                    <a:solidFill>
+                      <a:srgbClr val="FFFFFF"/>
+                    </a:solidFill>
+                  </a:tcPr>
+                </a:tc>
+                <a:tc>
+                  <a:txBody>
+                    <a:bodyPr wrap="square"/>
+                    <a:lstStyle/>
+                    <a:p>
+                      <a:r>
+                        <a:rPr sz="1100" b="0">
+                          <a:solidFill>
+                            <a:srgbClr val="141B2D"/>
+                          </a:solidFill>
+                          <a:latin typeface="Verdana"/>
+                        </a:rPr>
+                        <a:t>Ours: entered as one RRF vote over the pool the other legs found, never as a score over the catalog, and doubled only when the shopper asks us to choose.</a:t>
+                      </a:r>
+                    </a:p>
+                  </a:txBody>
+                  <a:tcPr marL="82296" marR="82296" marT="36576" marB="36576" anchor="ctr">
+                    <a:solidFill>
+                      <a:srgbClr val="FFFFFF"/>
+                    </a:solidFill>
+                  </a:tcPr>
+                </a:tc>
+                <a:tc>
+                  <a:txBody>
+                    <a:bodyPr wrap="square"/>
+                    <a:lstStyle/>
+                    <a:p>
+                      <a:r>
+                        <a:rPr sz="1100" b="1">
+                          <a:solidFill>
+                            <a:srgbClr val="0B7A4B"/>
+                          </a:solidFill>
+                          <a:latin typeface="Verdana"/>
+                        </a:rPr>
+                        <a:t>OURS</a:t>
+                      </a:r>
+                    </a:p>
+                  </a:txBody>
+                  <a:tcPr marL="82296" marR="82296" marT="36576" marB="36576" anchor="ctr">
+                    <a:solidFill>
+                      <a:srgbClr val="FFFFFF"/>
+                    </a:solidFill>
+                  </a:tcPr>
+                </a:tc>
+              </a:tr>
+              <a:tr h="777240">
+                <a:tc>
+                  <a:txBody>
+                    <a:bodyPr wrap="square"/>
+                    <a:lstStyle/>
+                    <a:p>
+                      <a:r>
+                        <a:rPr sz="1100" b="0">
+                          <a:solidFill>
+                            <a:srgbClr val="141B2D"/>
+                          </a:solidFill>
+                          <a:latin typeface="Verdana"/>
+                        </a:rPr>
+                        <a:t>Dropping shown items</a:t>
+                      </a:r>
+                    </a:p>
+                  </a:txBody>
+                  <a:tcPr marL="82296" marR="82296" marT="36576" marB="36576" anchor="ctr">
+                    <a:solidFill>
+                      <a:srgbClr val="F4F6FA"/>
+                    </a:solidFill>
+                  </a:tcPr>
+                </a:tc>
+                <a:tc>
+                  <a:txBody>
+                    <a:bodyPr wrap="square"/>
+                    <a:lstStyle/>
+                    <a:p>
+                      <a:r>
+                        <a:rPr sz="1100" b="0">
+                          <a:solidFill>
+                            <a:srgbClr val="141B2D"/>
+                          </a:solidFill>
+                          <a:latin typeface="Verdana"/>
+                        </a:rPr>
+                        <a:t>No paper. It falls out of reading the scorer.</a:t>
+                      </a:r>
+                    </a:p>
+                  </a:txBody>
+                  <a:tcPr marL="82296" marR="82296" marT="36576" marB="36576" anchor="ctr">
+                    <a:solidFill>
+                      <a:srgbClr val="F4F6FA"/>
+                    </a:solidFill>
+                  </a:tcPr>
+                </a:tc>
+                <a:tc>
+                  <a:txBody>
+                    <a:bodyPr wrap="square"/>
+                    <a:lstStyle/>
+                    <a:p>
+                      <a:r>
+                        <a:rPr sz="1100" b="0">
+                          <a:solidFill>
+                            <a:srgbClr val="141B2D"/>
+                          </a:solidFill>
+                          <a:latin typeface="Verdana"/>
+                        </a:rPr>
+                        <a:t>The session ends at first hit, so a further turn proves every item shown is wrong. Our largest single win, +0.084.</a:t>
+                      </a:r>
+                    </a:p>
+                  </a:txBody>
+                  <a:tcPr marL="82296" marR="82296" marT="36576" marB="36576" anchor="ctr">
+                    <a:solidFill>
+                      <a:srgbClr val="F4F6FA"/>
+                    </a:solidFill>
+                  </a:tcPr>
+                </a:tc>
+                <a:tc>
+                  <a:txBody>
+                    <a:bodyPr wrap="square"/>
+                    <a:lstStyle/>
+                    <a:p>
+                      <a:r>
+                        <a:rPr sz="1100" b="1">
+                          <a:solidFill>
+                            <a:srgbClr val="0B7A4B"/>
+                          </a:solidFill>
+                          <a:latin typeface="Verdana"/>
+                        </a:rPr>
+                        <a:t>OURS</a:t>
+                      </a:r>
+                    </a:p>
+                  </a:txBody>
+                  <a:tcPr marL="82296" marR="82296" marT="36576" marB="36576" anchor="ctr">
+                    <a:solidFill>
+                      <a:srgbClr val="F4F6FA"/>
+                    </a:solidFill>
+                  </a:tcPr>
+                </a:tc>
+              </a:tr>
+              <a:tr h="777240">
+                <a:tc>
+                  <a:txBody>
+                    <a:bodyPr wrap="square"/>
+                    <a:lstStyle/>
+                    <a:p>
+                      <a:r>
+                        <a:rPr sz="1100" b="0">
+                          <a:solidFill>
+                            <a:srgbClr val="141B2D"/>
+                          </a:solidFill>
+                          <a:latin typeface="Verdana"/>
+                        </a:rPr>
+                        <a:t>Boost, never filter</a:t>
+                      </a:r>
+                    </a:p>
+                  </a:txBody>
+                  <a:tcPr marL="82296" marR="82296" marT="36576" marB="36576" anchor="ctr">
+                    <a:solidFill>
+                      <a:srgbClr val="FFFFFF"/>
+                    </a:solidFill>
+                  </a:tcPr>
+                </a:tc>
+                <a:tc>
+                  <a:txBody>
+                    <a:bodyPr wrap="square"/>
+                    <a:lstStyle/>
+                    <a:p>
+                      <a:r>
+                        <a:rPr sz="1100" b="0">
+                          <a:solidFill>
+                            <a:srgbClr val="141B2D"/>
+                          </a:solidFill>
+                          <a:latin typeface="Verdana"/>
+                        </a:rPr>
+                        <a:t>Soft constraints are folklore; the failure mode here was measured.</a:t>
+                      </a:r>
+                    </a:p>
+                  </a:txBody>
+                  <a:tcPr marL="82296" marR="82296" marT="36576" marB="36576" anchor="ctr">
+                    <a:solidFill>
+                      <a:srgbClr val="FFFFFF"/>
+                    </a:solidFill>
+                  </a:tcPr>
+                </a:tc>
+                <a:tc>
+                  <a:txBody>
+                    <a:bodyPr wrap="square"/>
+                    <a:lstStyle/>
+                    <a:p>
+                      <a:r>
+                        <a:rPr sz="1100" b="0">
+                          <a:solidFill>
+                            <a:srgbClr val="141B2D"/>
+                          </a:solidFill>
+                          <a:latin typeface="Verdana"/>
+                        </a:rPr>
+                        <a:t>Our own attribute labels disagree with the target 16–37% of the time, so a hard filter deletes the answer. Agreement scores ±1 and deletes nothing.</a:t>
+                      </a:r>
+                    </a:p>
+                  </a:txBody>
+                  <a:tcPr marL="82296" marR="82296" marT="36576" marB="36576" anchor="ctr">
+                    <a:solidFill>
+                      <a:srgbClr val="FFFFFF"/>
+                    </a:solidFill>
+                  </a:tcPr>
+                </a:tc>
+                <a:tc>
+                  <a:txBody>
+                    <a:bodyPr wrap="square"/>
+                    <a:lstStyle/>
+                    <a:p>
+                      <a:r>
+                        <a:rPr sz="1100" b="1">
+                          <a:solidFill>
+                            <a:srgbClr val="0B7A4B"/>
+                          </a:solidFill>
+                          <a:latin typeface="Verdana"/>
+                        </a:rPr>
+                        <a:t>OURS</a:t>
+                      </a:r>
+                    </a:p>
+                  </a:txBody>
+                  <a:tcPr marL="82296" marR="82296" marT="36576" marB="36576" anchor="ctr">
+                    <a:solidFill>
+                      <a:srgbClr val="FFFFFF"/>
+                    </a:solidFill>
+                  </a:tcPr>
+                </a:tc>
+              </a:tr>
+            </a:tbl>
+          </a:graphicData>
+        </a:graphic>
+      </p:graphicFrame>
+      <p:sp>
+        <p:nvSpPr>
+          <p:cNvPr id="6" name="TextBox 5"/>
+          <p:cNvSpPr txBox="1"/>
+          <p:nvPr/>
+        </p:nvSpPr>
+        <p:spPr>
+          <a:xfrm>
+            <a:off x="640080" y="4617720"/>
+            <a:ext cx="10881360" cy="457200"/>
+          </a:xfrm>
+          <a:prstGeom prst="rect">
+            <a:avLst/>
+          </a:prstGeom>
+          <a:noFill/>
+        </p:spPr>
+        <p:txBody>
+          <a:bodyPr wrap="square" lIns="0" rIns="0" tIns="0" bIns="0">
+            <a:spAutoFit/>
+          </a:bodyPr>
+          <a:lstStyle/>
+          <a:p>
+            <a:r>
+              <a:rPr sz="1300" b="1">
+                <a:solidFill>
+                  <a:srgbClr val="0F62FE"/>
+                </a:solidFill>
+                <a:latin typeface="Verdana"/>
+              </a:rPr>
+              <a:t>Most of this deck's score came from these three rows and the adapted ones on the previous slide — every one of them measured, not assumed.</a:t>
+            </a:r>
+          </a:p>
+        </p:txBody>
+      </p:sp>
+    </p:spTree>
+  </p:cSld>
+  <p:clrMapOvr>
+    <a:masterClrMapping/>
+  </p:clrMapOvr>
+</p:sld>
+</file>
+
+<file path=ppt/slides/slide11.xml><?xml version="1.0" encoding="utf-8"?>
+<p:sld xmlns:a="http://schemas.openxmlformats.org/drawingml/2006/main" xmlns:p="http://schemas.openxmlformats.org/presentationml/2006/main" xmlns:r="http://schemas.openxmlformats.org/officeDocument/2006/relationships">
+  <p:cSld>
+    <p:spTree>
+      <p:nvGrpSpPr>
+        <p:cNvPr id="1" name=""/>
+        <p:cNvGrpSpPr/>
+        <p:nvPr/>
+      </p:nvGrpSpPr>
+      <p:grpSpPr/>
+      <p:sp>
+        <p:nvSpPr>
+          <p:cNvPr id="2" name="TextBox 1"/>
+          <p:cNvSpPr txBox="1"/>
+          <p:nvPr/>
+        </p:nvSpPr>
+        <p:spPr>
+          <a:xfrm>
+            <a:off x="640080" y="384048"/>
+            <a:ext cx="10881360" cy="274320"/>
+          </a:xfrm>
+          <a:prstGeom prst="rect">
+            <a:avLst/>
+          </a:prstGeom>
+          <a:noFill/>
+        </p:spPr>
+        <p:txBody>
+          <a:bodyPr wrap="square" lIns="0" rIns="0" tIns="0" bIns="0">
+            <a:spAutoFit/>
+          </a:bodyPr>
+          <a:lstStyle/>
+          <a:p>
+            <a:pPr>
+              <a:spcAft>
+                <a:spcPts val="0"/>
+              </a:spcAft>
+            </a:pPr>
+            <a:r>
+              <a:rPr sz="1100" b="1">
+                <a:solidFill>
+                  <a:srgbClr val="0F62FE"/>
+                </a:solidFill>
+                <a:latin typeface="Verdana"/>
+              </a:rPr>
+              <a:t>MECHANISM</a:t>
+            </a:r>
+          </a:p>
+        </p:txBody>
+      </p:sp>
+      <p:sp>
+        <p:nvSpPr>
+          <p:cNvPr id="3" name="TextBox 2"/>
+          <p:cNvSpPr txBox="1"/>
+          <p:nvPr/>
+        </p:nvSpPr>
+        <p:spPr>
+          <a:xfrm>
+            <a:off x="640080" y="658368"/>
+            <a:ext cx="10881360" cy="685800"/>
+          </a:xfrm>
+          <a:prstGeom prst="rect">
+            <a:avLst/>
+          </a:prstGeom>
+          <a:noFill/>
+        </p:spPr>
+        <p:txBody>
+          <a:bodyPr wrap="square" lIns="0" rIns="0" tIns="0" bIns="0">
+            <a:spAutoFit/>
+          </a:bodyPr>
+          <a:lstStyle/>
+          <a:p>
+            <a:r>
+              <a:rPr sz="2800" b="1">
+                <a:solidFill>
+                  <a:srgbClr val="141B2D"/>
+                </a:solidFill>
+                <a:latin typeface="Georgia"/>
+              </a:rPr>
+              <a:t>How LM eager prediction works</a:t>
+            </a:r>
+          </a:p>
+        </p:txBody>
+      </p:sp>
+      <p:sp>
+        <p:nvSpPr>
+          <p:cNvPr id="4" name="Rectangle 3"/>
+          <p:cNvSpPr/>
+          <p:nvPr/>
+        </p:nvSpPr>
+        <p:spPr>
+          <a:xfrm>
+            <a:off x="640080" y="1389888"/>
+            <a:ext cx="10908792" cy="9525"/>
+          </a:xfrm>
+          <a:prstGeom prst="rect">
+            <a:avLst/>
+          </a:prstGeom>
+          <a:solidFill>
+            <a:srgbClr val="D8DDE6"/>
+          </a:solidFill>
+          <a:ln>
+            <a:noFill/>
+          </a:ln>
+          <a:effectLst/>
+        </p:spPr>
+        <p:style>
+          <a:lnRef idx="1">
+            <a:schemeClr val="accent1"/>
+          </a:lnRef>
+          <a:fillRef idx="3">
+            <a:schemeClr val="accent1"/>
+          </a:fillRef>
+          <a:effectRef idx="2">
+            <a:schemeClr val="accent1"/>
+          </a:effectRef>
+          <a:fontRef idx="minor">
+            <a:schemeClr val="lt1"/>
+          </a:fontRef>
+        </p:style>
+        <p:txBody>
+          <a:bodyPr rtlCol="0" anchor="ctr"/>
+          <a:lstStyle/>
+          <a:p>
+            <a:pPr algn="ctr"/>
+          </a:p>
+        </p:txBody>
+      </p:sp>
+      <p:sp>
+        <p:nvSpPr>
+          <p:cNvPr id="5" name="TextBox 4"/>
+          <p:cNvSpPr txBox="1"/>
+          <p:nvPr/>
+        </p:nvSpPr>
+        <p:spPr>
+          <a:xfrm>
+            <a:off x="640080" y="1481328"/>
+            <a:ext cx="10881360" cy="365760"/>
+          </a:xfrm>
+          <a:prstGeom prst="rect">
+            <a:avLst/>
+          </a:prstGeom>
+          <a:noFill/>
+        </p:spPr>
+        <p:txBody>
+          <a:bodyPr wrap="square" lIns="0" rIns="0" tIns="0" bIns="0">
+            <a:spAutoFit/>
+          </a:bodyPr>
+          <a:lstStyle/>
+          <a:p>
+            <a:r>
+              <a:rPr sz="1400" b="1">
+                <a:solidFill>
+                  <a:srgbClr val="141B2D"/>
+                </a:solidFill>
+                <a:latin typeface="Verdana"/>
+              </a:rPr>
+              <a:t>Guess an attribute the shopper never stated, from what they already said — so we skip asking about it.</a:t>
+            </a:r>
+          </a:p>
+        </p:txBody>
+      </p:sp>
+      <p:sp>
+        <p:nvSpPr>
+          <p:cNvPr id="6" name="Rounded Rectangle 5"/>
+          <p:cNvSpPr/>
+          <p:nvPr/>
+        </p:nvSpPr>
+        <p:spPr>
+          <a:xfrm>
+            <a:off x="640080" y="2011680"/>
+            <a:ext cx="2468880" cy="960120"/>
+          </a:xfrm>
+          <a:prstGeom prst="roundRect">
+            <a:avLst/>
+          </a:prstGeom>
+          <a:solidFill>
+            <a:srgbClr val="F4F6FA"/>
+          </a:solidFill>
+          <a:ln w="12700">
+            <a:solidFill>
+              <a:srgbClr val="D8DDE6"/>
+            </a:solidFill>
+          </a:ln>
+          <a:effectLst/>
+        </p:spPr>
+        <p:style>
+          <a:lnRef idx="1">
+            <a:schemeClr val="accent1"/>
+          </a:lnRef>
+          <a:fillRef idx="3">
+            <a:schemeClr val="accent1"/>
+          </a:fillRef>
+          <a:effectRef idx="2">
+            <a:schemeClr val="accent1"/>
+          </a:effectRef>
+          <a:fontRef idx="minor">
+            <a:schemeClr val="lt1"/>
+          </a:fontRef>
+        </p:style>
+        <p:txBody>
+          <a:bodyPr rtlCol="0" anchor="ctr" wrap="square" lIns="73152" rIns="73152" tIns="36576" bIns="36576"/>
+          <a:lstStyle/>
+          <a:p>
+            <a:pPr algn="ctr">
+              <a:spcAft>
+                <a:spcPts val="0"/>
+              </a:spcAft>
+            </a:pPr>
+            <a:r>
+              <a:rPr sz="1250" b="1">
+                <a:solidFill>
+                  <a:srgbClr val="141B2D"/>
+                </a:solidFill>
+                <a:latin typeface="Verdana"/>
+              </a:rPr>
+              <a:t>1. Mask each candidate</a:t>
+            </a:r>
+          </a:p>
+          <a:p>
+            <a:pPr algn="ctr">
+              <a:spcAft>
+                <a:spcPts val="0"/>
+              </a:spcAft>
+            </a:pPr>
+            <a:r>
+              <a:rPr sz="1050" b="0">
+                <a:solidFill>
+                  <a:srgbClr val="5B667A"/>
+                </a:solidFill>
+                <a:latin typeface="Verdana"/>
+              </a:rPr>
+              <a:t>"...wants it made of [MASK]."</a:t>
+            </a:r>
+          </a:p>
+          <a:p>
+            <a:pPr algn="ctr">
+              <a:spcAft>
+                <a:spcPts val="0"/>
+              </a:spcAft>
+            </a:pPr>
+            <a:r>
+              <a:rPr sz="1050" b="0">
+                <a:solidFill>
+                  <a:srgbClr val="5B667A"/>
+                </a:solidFill>
+                <a:latin typeface="Verdana"/>
+              </a:rPr>
+              <a:t>one forward pass per token length,</a:t>
+            </a:r>
+          </a:p>
+          <a:p>
+            <a:pPr algn="ctr">
+              <a:spcAft>
+                <a:spcPts val="0"/>
+              </a:spcAft>
+            </a:pPr>
+            <a:r>
+              <a:rPr sz="1050" b="0">
+                <a:solidFill>
+                  <a:srgbClr val="5B667A"/>
+                </a:solidFill>
+                <a:latin typeface="Verdana"/>
+              </a:rPr>
+              <a:t>not per candidate value</a:t>
+            </a:r>
+          </a:p>
+        </p:txBody>
+      </p:sp>
+      <p:sp>
+        <p:nvSpPr>
+          <p:cNvPr id="7" name="Right Arrow 6"/>
+          <p:cNvSpPr/>
+          <p:nvPr/>
+        </p:nvSpPr>
+        <p:spPr>
+          <a:xfrm>
+            <a:off x="3145536" y="2391156"/>
+            <a:ext cx="292608" cy="201168"/>
+          </a:xfrm>
+          <a:prstGeom prst="rightArrow">
+            <a:avLst/>
+          </a:prstGeom>
+          <a:solidFill>
+            <a:srgbClr val="0F62FE"/>
+          </a:solidFill>
+          <a:ln>
+            <a:noFill/>
+          </a:ln>
+          <a:effectLst/>
+        </p:spPr>
+        <p:style>
+          <a:lnRef idx="1">
+            <a:schemeClr val="accent1"/>
+          </a:lnRef>
+          <a:fillRef idx="3">
+            <a:schemeClr val="accent1"/>
+          </a:fillRef>
+          <a:effectRef idx="2">
+            <a:schemeClr val="accent1"/>
+          </a:effectRef>
+          <a:fontRef idx="minor">
+            <a:schemeClr val="lt1"/>
+          </a:fontRef>
+        </p:style>
+        <p:txBody>
+          <a:bodyPr rtlCol="0" anchor="ctr"/>
+          <a:lstStyle/>
+          <a:p>
+            <a:pPr algn="ctr"/>
+          </a:p>
+        </p:txBody>
+      </p:sp>
+      <p:sp>
+        <p:nvSpPr>
+          <p:cNvPr id="8" name="Rounded Rectangle 7"/>
+          <p:cNvSpPr/>
+          <p:nvPr/>
+        </p:nvSpPr>
+        <p:spPr>
+          <a:xfrm>
+            <a:off x="3438144" y="2011680"/>
+            <a:ext cx="2468880" cy="960120"/>
+          </a:xfrm>
+          <a:prstGeom prst="roundRect">
+            <a:avLst/>
+          </a:prstGeom>
+          <a:solidFill>
+            <a:srgbClr val="F4F6FA"/>
+          </a:solidFill>
+          <a:ln w="12700">
+            <a:solidFill>
+              <a:srgbClr val="D8DDE6"/>
+            </a:solidFill>
+          </a:ln>
+          <a:effectLst/>
+        </p:spPr>
+        <p:style>
+          <a:lnRef idx="1">
+            <a:schemeClr val="accent1"/>
+          </a:lnRef>
+          <a:fillRef idx="3">
+            <a:schemeClr val="accent1"/>
+          </a:fillRef>
+          <a:effectRef idx="2">
+            <a:schemeClr val="accent1"/>
+          </a:effectRef>
+          <a:fontRef idx="minor">
+            <a:schemeClr val="lt1"/>
+          </a:fontRef>
+        </p:style>
+        <p:txBody>
+          <a:bodyPr rtlCol="0" anchor="ctr" wrap="square" lIns="73152" rIns="73152" tIns="36576" bIns="36576"/>
+          <a:lstStyle/>
+          <a:p>
+            <a:pPr algn="ctr">
+              <a:spcAft>
+                <a:spcPts val="0"/>
+              </a:spcAft>
+            </a:pPr>
+            <a:r>
+              <a:rPr sz="1250" b="1">
+                <a:solidFill>
+                  <a:srgbClr val="141B2D"/>
+                </a:solidFill>
+                <a:latin typeface="Verdana"/>
+              </a:rPr>
+              <a:t>2. Score, length-normalize</a:t>
+            </a:r>
+          </a:p>
+          <a:p>
+            <a:pPr algn="ctr">
+              <a:spcAft>
+                <a:spcPts val="0"/>
+              </a:spcAft>
+            </a:pPr>
+            <a:r>
+              <a:rPr sz="1050" b="0">
+                <a:solidFill>
+                  <a:srgbClr val="5B667A"/>
+                </a:solidFill>
+                <a:latin typeface="Verdana"/>
+              </a:rPr>
+              <a:t>sum log p(token) over the mask(s),</a:t>
+            </a:r>
+          </a:p>
+          <a:p>
+            <a:pPr algn="ctr">
+              <a:spcAft>
+                <a:spcPts val="0"/>
+              </a:spcAft>
+            </a:pPr>
+            <a:r>
+              <a:rPr sz="1050" b="0">
+                <a:solidFill>
+                  <a:srgbClr val="5B667A"/>
+                </a:solidFill>
+                <a:latin typeface="Verdana"/>
+              </a:rPr>
+              <a:t>divided by token count —</a:t>
+            </a:r>
+          </a:p>
+          <a:p>
+            <a:pPr algn="ctr">
+              <a:spcAft>
+                <a:spcPts val="0"/>
+              </a:spcAft>
+            </a:pPr>
+            <a:r>
+              <a:rPr sz="1050" b="0">
+                <a:solidFill>
+                  <a:srgbClr val="5B667A"/>
+                </a:solidFill>
+                <a:latin typeface="Verdana"/>
+              </a:rPr>
+              <a:t>pseudo-log-likelihood</a:t>
+            </a:r>
+          </a:p>
+        </p:txBody>
+      </p:sp>
+      <p:sp>
+        <p:nvSpPr>
+          <p:cNvPr id="9" name="Right Arrow 8"/>
+          <p:cNvSpPr/>
+          <p:nvPr/>
+        </p:nvSpPr>
+        <p:spPr>
+          <a:xfrm>
+            <a:off x="5943600" y="2391156"/>
+            <a:ext cx="292608" cy="201168"/>
+          </a:xfrm>
+          <a:prstGeom prst="rightArrow">
+            <a:avLst/>
+          </a:prstGeom>
+          <a:solidFill>
+            <a:srgbClr val="0F62FE"/>
+          </a:solidFill>
+          <a:ln>
+            <a:noFill/>
+          </a:ln>
+          <a:effectLst/>
+        </p:spPr>
+        <p:style>
+          <a:lnRef idx="1">
+            <a:schemeClr val="accent1"/>
+          </a:lnRef>
+          <a:fillRef idx="3">
+            <a:schemeClr val="accent1"/>
+          </a:fillRef>
+          <a:effectRef idx="2">
+            <a:schemeClr val="accent1"/>
+          </a:effectRef>
+          <a:fontRef idx="minor">
+            <a:schemeClr val="lt1"/>
+          </a:fontRef>
+        </p:style>
+        <p:txBody>
+          <a:bodyPr rtlCol="0" anchor="ctr"/>
+          <a:lstStyle/>
+          <a:p>
+            <a:pPr algn="ctr"/>
+          </a:p>
+        </p:txBody>
+      </p:sp>
+      <p:sp>
+        <p:nvSpPr>
+          <p:cNvPr id="10" name="Rounded Rectangle 9"/>
+          <p:cNvSpPr/>
+          <p:nvPr/>
+        </p:nvSpPr>
+        <p:spPr>
+          <a:xfrm>
+            <a:off x="6236208" y="2011680"/>
+            <a:ext cx="2468880" cy="960120"/>
+          </a:xfrm>
+          <a:prstGeom prst="roundRect">
+            <a:avLst/>
+          </a:prstGeom>
+          <a:solidFill>
+            <a:srgbClr val="F4F6FA"/>
+          </a:solidFill>
+          <a:ln w="12700">
+            <a:solidFill>
+              <a:srgbClr val="D8DDE6"/>
+            </a:solidFill>
+          </a:ln>
+          <a:effectLst/>
+        </p:spPr>
+        <p:style>
+          <a:lnRef idx="1">
+            <a:schemeClr val="accent1"/>
+          </a:lnRef>
+          <a:fillRef idx="3">
+            <a:schemeClr val="accent1"/>
+          </a:fillRef>
+          <a:effectRef idx="2">
+            <a:schemeClr val="accent1"/>
+          </a:effectRef>
+          <a:fontRef idx="minor">
+            <a:schemeClr val="lt1"/>
+          </a:fontRef>
+        </p:style>
+        <p:txBody>
+          <a:bodyPr rtlCol="0" anchor="ctr" wrap="square" lIns="73152" rIns="73152" tIns="36576" bIns="36576"/>
+          <a:lstStyle/>
+          <a:p>
+            <a:pPr algn="ctr">
+              <a:spcAft>
+                <a:spcPts val="0"/>
+              </a:spcAft>
+            </a:pPr>
+            <a:r>
+              <a:rPr sz="1250" b="1">
+                <a:solidFill>
+                  <a:srgbClr val="141B2D"/>
+                </a:solidFill>
+                <a:latin typeface="Verdana"/>
+              </a:rPr>
+              <a:t>3. Softmax, take entropy</a:t>
+            </a:r>
+          </a:p>
+          <a:p>
+            <a:pPr algn="ctr">
+              <a:spcAft>
+                <a:spcPts val="0"/>
+              </a:spcAft>
+            </a:pPr>
+            <a:r>
+              <a:rPr sz="1050" b="0">
+                <a:solidFill>
+                  <a:srgbClr val="5B667A"/>
+                </a:solidFill>
+                <a:latin typeface="Verdana"/>
+              </a:rPr>
+              <a:t>distribution over the closed</a:t>
+            </a:r>
+          </a:p>
+          <a:p>
+            <a:pPr algn="ctr">
+              <a:spcAft>
+                <a:spcPts val="0"/>
+              </a:spcAft>
+            </a:pPr>
+            <a:r>
+              <a:rPr sz="1050" b="0">
+                <a:solidFill>
+                  <a:srgbClr val="5B667A"/>
+                </a:solidFill>
+                <a:latin typeface="Verdana"/>
+              </a:rPr>
+              <a:t>vocabulary; normalized Shannon</a:t>
+            </a:r>
+          </a:p>
+          <a:p>
+            <a:pPr algn="ctr">
+              <a:spcAft>
+                <a:spcPts val="0"/>
+              </a:spcAft>
+            </a:pPr>
+            <a:r>
+              <a:rPr sz="1050" b="0">
+                <a:solidFill>
+                  <a:srgbClr val="5B667A"/>
+                </a:solidFill>
+                <a:latin typeface="Verdana"/>
+              </a:rPr>
+              <a:t>entropy of that distribution</a:t>
+            </a:r>
+          </a:p>
+        </p:txBody>
+      </p:sp>
+      <p:sp>
+        <p:nvSpPr>
+          <p:cNvPr id="11" name="Right Arrow 10"/>
+          <p:cNvSpPr/>
+          <p:nvPr/>
+        </p:nvSpPr>
+        <p:spPr>
+          <a:xfrm>
+            <a:off x="8741664" y="2391156"/>
+            <a:ext cx="292608" cy="201168"/>
+          </a:xfrm>
+          <a:prstGeom prst="rightArrow">
+            <a:avLst/>
+          </a:prstGeom>
+          <a:solidFill>
+            <a:srgbClr val="0F62FE"/>
+          </a:solidFill>
+          <a:ln>
+            <a:noFill/>
+          </a:ln>
+          <a:effectLst/>
+        </p:spPr>
+        <p:style>
+          <a:lnRef idx="1">
+            <a:schemeClr val="accent1"/>
+          </a:lnRef>
+          <a:fillRef idx="3">
+            <a:schemeClr val="accent1"/>
+          </a:fillRef>
+          <a:effectRef idx="2">
+            <a:schemeClr val="accent1"/>
+          </a:effectRef>
+          <a:fontRef idx="minor">
+            <a:schemeClr val="lt1"/>
+          </a:fontRef>
+        </p:style>
+        <p:txBody>
+          <a:bodyPr rtlCol="0" anchor="ctr"/>
+          <a:lstStyle/>
+          <a:p>
+            <a:pPr algn="ctr"/>
+          </a:p>
+        </p:txBody>
+      </p:sp>
+      <p:sp>
+        <p:nvSpPr>
+          <p:cNvPr id="12" name="Rounded Rectangle 11"/>
+          <p:cNvSpPr/>
+          <p:nvPr/>
+        </p:nvSpPr>
+        <p:spPr>
+          <a:xfrm>
+            <a:off x="9034272" y="2011680"/>
+            <a:ext cx="2331720" cy="960120"/>
+          </a:xfrm>
+          <a:prstGeom prst="roundRect">
+            <a:avLst/>
+          </a:prstGeom>
+          <a:solidFill>
+            <a:srgbClr val="E4EDFD"/>
+          </a:solidFill>
+          <a:ln w="12700">
+            <a:solidFill>
+              <a:srgbClr val="0F62FE"/>
+            </a:solidFill>
+          </a:ln>
+          <a:effectLst/>
+        </p:spPr>
+        <p:style>
+          <a:lnRef idx="1">
+            <a:schemeClr val="accent1"/>
+          </a:lnRef>
+          <a:fillRef idx="3">
+            <a:schemeClr val="accent1"/>
+          </a:fillRef>
+          <a:effectRef idx="2">
+            <a:schemeClr val="accent1"/>
+          </a:effectRef>
+          <a:fontRef idx="minor">
+            <a:schemeClr val="lt1"/>
+          </a:fontRef>
+        </p:style>
+        <p:txBody>
+          <a:bodyPr rtlCol="0" anchor="ctr" wrap="square" lIns="73152" rIns="73152" tIns="36576" bIns="36576"/>
+          <a:lstStyle/>
+          <a:p>
+            <a:pPr algn="ctr">
+              <a:spcAft>
+                <a:spcPts val="0"/>
+              </a:spcAft>
+            </a:pPr>
+            <a:r>
+              <a:rPr sz="1250" b="1">
+                <a:solidFill>
+                  <a:srgbClr val="0F62FE"/>
+                </a:solidFill>
+                <a:latin typeface="Verdana"/>
+              </a:rPr>
+              <a:t>4. Gate at H &lt; 0.60</a:t>
+            </a:r>
+          </a:p>
+          <a:p>
+            <a:pPr algn="ctr">
+              <a:spcAft>
+                <a:spcPts val="0"/>
+              </a:spcAft>
+            </a:pPr>
+            <a:r>
+              <a:rPr sz="1050" b="0">
+                <a:solidFill>
+                  <a:srgbClr val="5B667A"/>
+                </a:solidFill>
+                <a:latin typeface="Verdana"/>
+              </a:rPr>
+              <a:t>calibrated in</a:t>
+            </a:r>
+          </a:p>
+          <a:p>
+            <a:pPr algn="ctr">
+              <a:spcAft>
+                <a:spcPts val="0"/>
+              </a:spcAft>
+            </a:pPr>
+            <a:r>
+              <a:rPr sz="1050" b="0">
+                <a:solidFill>
+                  <a:srgbClr val="5B667A"/>
+                </a:solidFill>
+                <a:latin typeface="Verdana"/>
+              </a:rPr>
+              <a:t>eval_lm_confidence.py,</a:t>
+            </a:r>
+          </a:p>
+          <a:p>
+            <a:pPr algn="ctr">
+              <a:spcAft>
+                <a:spcPts val="0"/>
+              </a:spcAft>
+            </a:pPr>
+            <a:r>
+              <a:rPr sz="1050" b="0">
+                <a:solidFill>
+                  <a:srgbClr val="5B667A"/>
+                </a:solidFill>
+                <a:latin typeface="Verdana"/>
+              </a:rPr>
+              <a:t>not guessed</a:t>
+            </a:r>
+          </a:p>
+        </p:txBody>
+      </p:sp>
+      <p:sp>
+        <p:nvSpPr>
+          <p:cNvPr id="13" name="Rounded Rectangle 12"/>
+          <p:cNvSpPr/>
+          <p:nvPr/>
+        </p:nvSpPr>
+        <p:spPr>
+          <a:xfrm>
+            <a:off x="640080" y="3337560"/>
+            <a:ext cx="10908792" cy="868680"/>
+          </a:xfrm>
+          <a:prstGeom prst="roundRect">
+            <a:avLst/>
+          </a:prstGeom>
+          <a:solidFill>
+            <a:srgbClr val="F4F6FA"/>
+          </a:solidFill>
+          <a:ln w="12700">
+            <a:solidFill>
+              <a:srgbClr val="D8DDE6"/>
+            </a:solidFill>
+          </a:ln>
+          <a:effectLst/>
+        </p:spPr>
+        <p:style>
+          <a:lnRef idx="1">
+            <a:schemeClr val="accent1"/>
+          </a:lnRef>
+          <a:fillRef idx="3">
+            <a:schemeClr val="accent1"/>
+          </a:fillRef>
+          <a:effectRef idx="2">
+            <a:schemeClr val="accent1"/>
+          </a:effectRef>
+          <a:fontRef idx="minor">
+            <a:schemeClr val="lt1"/>
+          </a:fontRef>
+        </p:style>
+        <p:txBody>
+          <a:bodyPr rtlCol="0" anchor="ctr" wrap="square" lIns="73152" rIns="73152" tIns="36576" bIns="36576"/>
+          <a:lstStyle/>
+          <a:p>
+            <a:pPr algn="ctr">
+              <a:spcAft>
+                <a:spcPts val="0"/>
+              </a:spcAft>
+            </a:pPr>
+            <a:r>
+              <a:rPr sz="1300" b="1">
+                <a:solidFill>
+                  <a:srgbClr val="141B2D"/>
+                </a:solidFill>
+                <a:latin typeface="Verdana"/>
+              </a:rPr>
+              <a:t>Only fills gaps</a:t>
+            </a:r>
+          </a:p>
+          <a:p>
+            <a:pPr algn="ctr">
+              <a:spcAft>
+                <a:spcPts val="0"/>
+              </a:spcAft>
+            </a:pPr>
+            <a:r>
+              <a:rPr sz="1200" b="0">
+                <a:solidFill>
+                  <a:srgbClr val="5B667A"/>
+                </a:solidFill>
+                <a:latin typeface="Verdana"/>
+              </a:rPr>
+              <a:t>Runs once per turn, per attribute NOT already in `disclosed` — a real answer is never second-guessed by a guess. If nothing clears the entropy gate, the turn proceeds exactly as if the mechanism did not exist. (starter/agent.py:_infer_attributes)</a:t>
+            </a:r>
+          </a:p>
+        </p:txBody>
+      </p:sp>
+      <p:sp>
+        <p:nvSpPr>
+          <p:cNvPr id="14" name="Rounded Rectangle 13"/>
+          <p:cNvSpPr/>
+          <p:nvPr/>
+        </p:nvSpPr>
+        <p:spPr>
+          <a:xfrm>
+            <a:off x="640080" y="4343400"/>
+            <a:ext cx="10908792" cy="1691640"/>
+          </a:xfrm>
+          <a:prstGeom prst="roundRect">
+            <a:avLst/>
+          </a:prstGeom>
+          <a:solidFill>
+            <a:srgbClr val="E4EDFD"/>
+          </a:solidFill>
+          <a:ln w="12700">
+            <a:solidFill>
+              <a:srgbClr val="0F62FE"/>
+            </a:solidFill>
+          </a:ln>
+          <a:effectLst/>
+        </p:spPr>
+        <p:style>
+          <a:lnRef idx="1">
+            <a:schemeClr val="accent1"/>
+          </a:lnRef>
+          <a:fillRef idx="3">
+            <a:schemeClr val="accent1"/>
+          </a:fillRef>
+          <a:effectRef idx="2">
+            <a:schemeClr val="accent1"/>
+          </a:effectRef>
+          <a:fontRef idx="minor">
+            <a:schemeClr val="lt1"/>
+          </a:fontRef>
+        </p:style>
+        <p:txBody>
+          <a:bodyPr rtlCol="0" anchor="ctr" wrap="square" lIns="73152" rIns="73152" tIns="36576" bIns="36576"/>
+          <a:lstStyle/>
+          <a:p>
+            <a:pPr algn="ctr">
+              <a:spcAft>
+                <a:spcPts val="0"/>
+              </a:spcAft>
+            </a:pPr>
+            <a:r>
+              <a:rPr sz="1250" b="1">
+                <a:solidFill>
+                  <a:srgbClr val="0F62FE"/>
+                </a:solidFill>
+                <a:latin typeface="Verdana"/>
+              </a:rPr>
+              <a:t>Measured, and shipped optional because of what was measured</a:t>
+            </a:r>
+          </a:p>
+          <a:p>
+            <a:pPr algn="ctr">
+              <a:spcAft>
+                <a:spcPts val="0"/>
+              </a:spcAft>
+            </a:pPr>
+            <a:r>
+              <a:rPr sz="1150" b="0">
+                <a:solidFill>
+                  <a:srgbClr val="5B667A"/>
+                </a:solidFill>
+                <a:latin typeface="Verdana"/>
+              </a:rPr>
+              <a:t>Calibration held for material — accuracy rises with the gate, so 0.60 is a real cutoff, not decoration. Colour was excluded: it loses to an always-"black" baseline and its gate runs backwards, so scoring it would launder noise as confidence.</a:t>
+            </a:r>
+          </a:p>
+          <a:p>
+            <a:pPr algn="ctr">
+              <a:spcAft>
+                <a:spcPts val="0"/>
+              </a:spcAft>
+            </a:pPr>
+            <a:r>
+              <a:rPr sz="1150" b="0">
+                <a:solidFill>
+                  <a:srgbClr val="5B667A"/>
+                </a:solidFill>
+                <a:latin typeface="Verdana"/>
+              </a:rPr>
+              <a:t>Ablating the whole mechanism moves TechnicalScore by +0.0010 — inside the noise floor, and the sign flips to -0.0007 under the no-dense configuration. For 257 MB of weights and ~47 ms/turn, that is not a trade worth making by default: it ships off, opt in with `fetch_assets.py --with-lm`, and the agent degrades to zero inferred attributes without it.</a:t>
+            </a:r>
+          </a:p>
+        </p:txBody>
+      </p:sp>
+    </p:spTree>
+  </p:cSld>
+  <p:clrMapOvr>
+    <a:masterClrMapping/>
+  </p:clrMapOvr>
+</p:sld>
+</file>
+
+<file path=ppt/slides/slide12.xml><?xml version="1.0" encoding="utf-8"?>
+<p:sld xmlns:a="http://schemas.openxmlformats.org/drawingml/2006/main" xmlns:p="http://schemas.openxmlformats.org/presentationml/2006/main" xmlns:r="http://schemas.openxmlformats.org/officeDocument/2006/relationships">
+  <p:cSld>
+    <p:spTree>
+      <p:nvGrpSpPr>
+        <p:cNvPr id="1" name=""/>
+        <p:cNvGrpSpPr/>
+        <p:nvPr/>
+      </p:nvGrpSpPr>
+      <p:grpSpPr/>
+      <p:sp>
+        <p:nvSpPr>
+          <p:cNvPr id="2" name="TextBox 1"/>
+          <p:cNvSpPr txBox="1"/>
+          <p:nvPr/>
+        </p:nvSpPr>
+        <p:spPr>
+          <a:xfrm>
+            <a:off x="640080" y="384048"/>
+            <a:ext cx="10881360" cy="274320"/>
+          </a:xfrm>
+          <a:prstGeom prst="rect">
+            <a:avLst/>
+          </a:prstGeom>
+          <a:noFill/>
+        </p:spPr>
+        <p:txBody>
+          <a:bodyPr wrap="square" lIns="0" rIns="0" tIns="0" bIns="0">
+            <a:spAutoFit/>
+          </a:bodyPr>
+          <a:lstStyle/>
+          <a:p>
+            <a:pPr>
+              <a:spcAft>
+                <a:spcPts val="0"/>
+              </a:spcAft>
+            </a:pPr>
+            <a:r>
+              <a:rPr sz="1100" b="1">
+                <a:solidFill>
+                  <a:srgbClr val="0F62FE"/>
+                </a:solidFill>
+                <a:latin typeface="Verdana"/>
+              </a:rPr>
               <a:t>THE LEDGER</a:t>
             </a:r>
           </a:p>
@@ -5283,7 +6738,7 @@
 </p:sld>
 </file>
 
-<file path=ppt/slides/slide11.xml><?xml version="1.0" encoding="utf-8"?>
+<file path=ppt/slides/slide13.xml><?xml version="1.0" encoding="utf-8"?>
 <p:sld xmlns:a="http://schemas.openxmlformats.org/drawingml/2006/main" xmlns:p="http://schemas.openxmlformats.org/presentationml/2006/main" xmlns:r="http://schemas.openxmlformats.org/officeDocument/2006/relationships">
   <p:cSld>
     <p:spTree>
@@ -6100,7 +7555,7 @@
 </p:sld>
 </file>
 
-<file path=ppt/slides/slide12.xml><?xml version="1.0" encoding="utf-8"?>
+<file path=ppt/slides/slide14.xml><?xml version="1.0" encoding="utf-8"?>
 <p:sld xmlns:a="http://schemas.openxmlformats.org/drawingml/2006/main" xmlns:p="http://schemas.openxmlformats.org/presentationml/2006/main" xmlns:r="http://schemas.openxmlformats.org/officeDocument/2006/relationships">
   <p:cSld>
     <p:spTree>
@@ -7250,7 +8705,7 @@
 </p:sld>
 </file>
 
-<file path=ppt/slides/slide13.xml><?xml version="1.0" encoding="utf-8"?>
+<file path=ppt/slides/slide15.xml><?xml version="1.0" encoding="utf-8"?>
 <p:sld xmlns:a="http://schemas.openxmlformats.org/drawingml/2006/main" xmlns:p="http://schemas.openxmlformats.org/presentationml/2006/main" xmlns:r="http://schemas.openxmlformats.org/officeDocument/2006/relationships">
   <p:cSld>
     <p:spTree>
@@ -8022,7 +9477,7 @@
 </p:sld>
 </file>
 
-<file path=ppt/slides/slide14.xml><?xml version="1.0" encoding="utf-8"?>
+<file path=ppt/slides/slide16.xml><?xml version="1.0" encoding="utf-8"?>
 <p:sld xmlns:a="http://schemas.openxmlformats.org/drawingml/2006/main" xmlns:p="http://schemas.openxmlformats.org/presentationml/2006/main" xmlns:r="http://schemas.openxmlformats.org/officeDocument/2006/relationships">
   <p:cSld>
     <p:spTree>
@@ -9328,7 +10783,7 @@
 </p:sld>
 </file>
 
-<file path=ppt/slides/slide15.xml><?xml version="1.0" encoding="utf-8"?>
+<file path=ppt/slides/slide17.xml><?xml version="1.0" encoding="utf-8"?>
 <p:sld xmlns:a="http://schemas.openxmlformats.org/drawingml/2006/main" xmlns:p="http://schemas.openxmlformats.org/presentationml/2006/main" xmlns:r="http://schemas.openxmlformats.org/officeDocument/2006/relationships">
   <p:cSld>
     <p:spTree>
@@ -9884,7 +11339,7 @@
 </p:sld>
 </file>
 
-<file path=ppt/slides/slide16.xml><?xml version="1.0" encoding="utf-8"?>
+<file path=ppt/slides/slide18.xml><?xml version="1.0" encoding="utf-8"?>
 <p:sld xmlns:a="http://schemas.openxmlformats.org/drawingml/2006/main" xmlns:p="http://schemas.openxmlformats.org/presentationml/2006/main" xmlns:r="http://schemas.openxmlformats.org/officeDocument/2006/relationships">
   <p:cSld>
     <p:spTree>
@@ -10752,7 +12207,1850 @@
 </p:sld>
 </file>
 
-<file path=ppt/slides/slide17.xml><?xml version="1.0" encoding="utf-8"?>
+<file path=ppt/slides/slide19.xml><?xml version="1.0" encoding="utf-8"?>
+<p:sld xmlns:a="http://schemas.openxmlformats.org/drawingml/2006/main" xmlns:p="http://schemas.openxmlformats.org/presentationml/2006/main" xmlns:r="http://schemas.openxmlformats.org/officeDocument/2006/relationships">
+  <p:cSld>
+    <p:spTree>
+      <p:nvGrpSpPr>
+        <p:cNvPr id="1" name=""/>
+        <p:cNvGrpSpPr/>
+        <p:nvPr/>
+      </p:nvGrpSpPr>
+      <p:grpSpPr/>
+      <p:sp>
+        <p:nvSpPr>
+          <p:cNvPr id="2" name="TextBox 1"/>
+          <p:cNvSpPr txBox="1"/>
+          <p:nvPr/>
+        </p:nvSpPr>
+        <p:spPr>
+          <a:xfrm>
+            <a:off x="640080" y="384048"/>
+            <a:ext cx="10881360" cy="274320"/>
+          </a:xfrm>
+          <a:prstGeom prst="rect">
+            <a:avLst/>
+          </a:prstGeom>
+          <a:noFill/>
+        </p:spPr>
+        <p:txBody>
+          <a:bodyPr wrap="square" lIns="0" rIns="0" tIns="0" bIns="0">
+            <a:spAutoFit/>
+          </a:bodyPr>
+          <a:lstStyle/>
+          <a:p>
+            <a:pPr>
+              <a:spcAft>
+                <a:spcPts val="0"/>
+              </a:spcAft>
+            </a:pPr>
+            <a:r>
+              <a:rPr sz="1100" b="1">
+                <a:solidFill>
+                  <a:srgbClr val="0F62FE"/>
+                </a:solidFill>
+                <a:latin typeface="Verdana"/>
+              </a:rPr>
+              <a:t>WORKFLOW</a:t>
+            </a:r>
+          </a:p>
+        </p:txBody>
+      </p:sp>
+      <p:sp>
+        <p:nvSpPr>
+          <p:cNvPr id="3" name="TextBox 2"/>
+          <p:cNvSpPr txBox="1"/>
+          <p:nvPr/>
+        </p:nvSpPr>
+        <p:spPr>
+          <a:xfrm>
+            <a:off x="640080" y="658368"/>
+            <a:ext cx="10881360" cy="685800"/>
+          </a:xfrm>
+          <a:prstGeom prst="rect">
+            <a:avLst/>
+          </a:prstGeom>
+          <a:noFill/>
+        </p:spPr>
+        <p:txBody>
+          <a:bodyPr wrap="square" lIns="0" rIns="0" tIns="0" bIns="0">
+            <a:spAutoFit/>
+          </a:bodyPr>
+          <a:lstStyle/>
+          <a:p>
+            <a:r>
+              <a:rPr sz="2800" b="1">
+                <a:solidFill>
+                  <a:srgbClr val="141B2D"/>
+                </a:solidFill>
+                <a:latin typeface="Georgia"/>
+              </a:rPr>
+              <a:t>How every change on this project got made</a:t>
+            </a:r>
+          </a:p>
+        </p:txBody>
+      </p:sp>
+      <p:sp>
+        <p:nvSpPr>
+          <p:cNvPr id="4" name="Rectangle 3"/>
+          <p:cNvSpPr/>
+          <p:nvPr/>
+        </p:nvSpPr>
+        <p:spPr>
+          <a:xfrm>
+            <a:off x="640080" y="1389888"/>
+            <a:ext cx="10908792" cy="9525"/>
+          </a:xfrm>
+          <a:prstGeom prst="rect">
+            <a:avLst/>
+          </a:prstGeom>
+          <a:solidFill>
+            <a:srgbClr val="D8DDE6"/>
+          </a:solidFill>
+          <a:ln>
+            <a:noFill/>
+          </a:ln>
+          <a:effectLst/>
+        </p:spPr>
+        <p:style>
+          <a:lnRef idx="1">
+            <a:schemeClr val="accent1"/>
+          </a:lnRef>
+          <a:fillRef idx="3">
+            <a:schemeClr val="accent1"/>
+          </a:fillRef>
+          <a:effectRef idx="2">
+            <a:schemeClr val="accent1"/>
+          </a:effectRef>
+          <a:fontRef idx="minor">
+            <a:schemeClr val="lt1"/>
+          </a:fontRef>
+        </p:style>
+        <p:txBody>
+          <a:bodyPr rtlCol="0" anchor="ctr"/>
+          <a:lstStyle/>
+          <a:p>
+            <a:pPr algn="ctr"/>
+          </a:p>
+        </p:txBody>
+      </p:sp>
+      <p:sp>
+        <p:nvSpPr>
+          <p:cNvPr id="5" name="Rounded Rectangle 4"/>
+          <p:cNvSpPr/>
+          <p:nvPr/>
+        </p:nvSpPr>
+        <p:spPr>
+          <a:xfrm>
+            <a:off x="685800" y="1828800"/>
+            <a:ext cx="3246120" cy="1417320"/>
+          </a:xfrm>
+          <a:prstGeom prst="roundRect">
+            <a:avLst/>
+          </a:prstGeom>
+          <a:solidFill>
+            <a:srgbClr val="F4F6FA"/>
+          </a:solidFill>
+          <a:ln w="12700">
+            <a:solidFill>
+              <a:srgbClr val="D8DDE6"/>
+            </a:solidFill>
+          </a:ln>
+          <a:effectLst/>
+        </p:spPr>
+        <p:style>
+          <a:lnRef idx="1">
+            <a:schemeClr val="accent1"/>
+          </a:lnRef>
+          <a:fillRef idx="3">
+            <a:schemeClr val="accent1"/>
+          </a:fillRef>
+          <a:effectRef idx="2">
+            <a:schemeClr val="accent1"/>
+          </a:effectRef>
+          <a:fontRef idx="minor">
+            <a:schemeClr val="lt1"/>
+          </a:fontRef>
+        </p:style>
+        <p:txBody>
+          <a:bodyPr rtlCol="0" anchor="ctr" wrap="square" lIns="73152" rIns="73152" tIns="36576" bIns="36576"/>
+          <a:lstStyle/>
+          <a:p>
+            <a:pPr algn="ctr">
+              <a:spcAft>
+                <a:spcPts val="0"/>
+              </a:spcAft>
+            </a:pPr>
+            <a:r>
+              <a:rPr sz="1400" b="1">
+                <a:solidFill>
+                  <a:srgbClr val="141B2D"/>
+                </a:solidFill>
+                <a:latin typeface="Verdana"/>
+              </a:rPr>
+              <a:t>1. GENERATE IDEA</a:t>
+            </a:r>
+          </a:p>
+          <a:p>
+            <a:pPr algn="ctr">
+              <a:spcAft>
+                <a:spcPts val="0"/>
+              </a:spcAft>
+            </a:pPr>
+            <a:r>
+              <a:rPr sz="1200" b="0">
+                <a:solidFill>
+                  <a:srgbClr val="5B667A"/>
+                </a:solidFill>
+                <a:latin typeface="Verdana"/>
+              </a:rPr>
+              <a:t>A hypothesis from reading the scorer,</a:t>
+            </a:r>
+          </a:p>
+          <a:p>
+            <a:pPr algn="ctr">
+              <a:spcAft>
+                <a:spcPts val="0"/>
+              </a:spcAft>
+            </a:pPr>
+            <a:r>
+              <a:rPr sz="1200" b="0">
+                <a:solidFill>
+                  <a:srgbClr val="5B667A"/>
+                </a:solidFill>
+                <a:latin typeface="Verdana"/>
+              </a:rPr>
+              <a:t>a miss census, or a prior rejection</a:t>
+            </a:r>
+          </a:p>
+        </p:txBody>
+      </p:sp>
+      <p:sp>
+        <p:nvSpPr>
+          <p:cNvPr id="6" name="Right Arrow 5"/>
+          <p:cNvSpPr/>
+          <p:nvPr/>
+        </p:nvSpPr>
+        <p:spPr>
+          <a:xfrm>
+            <a:off x="3977640" y="2414016"/>
+            <a:ext cx="411480" cy="201168"/>
+          </a:xfrm>
+          <a:prstGeom prst="rightArrow">
+            <a:avLst/>
+          </a:prstGeom>
+          <a:solidFill>
+            <a:srgbClr val="0F62FE"/>
+          </a:solidFill>
+          <a:ln>
+            <a:noFill/>
+          </a:ln>
+          <a:effectLst/>
+        </p:spPr>
+        <p:style>
+          <a:lnRef idx="1">
+            <a:schemeClr val="accent1"/>
+          </a:lnRef>
+          <a:fillRef idx="3">
+            <a:schemeClr val="accent1"/>
+          </a:fillRef>
+          <a:effectRef idx="2">
+            <a:schemeClr val="accent1"/>
+          </a:effectRef>
+          <a:fontRef idx="minor">
+            <a:schemeClr val="lt1"/>
+          </a:fontRef>
+        </p:style>
+        <p:txBody>
+          <a:bodyPr rtlCol="0" anchor="ctr"/>
+          <a:lstStyle/>
+          <a:p>
+            <a:pPr algn="ctr"/>
+          </a:p>
+        </p:txBody>
+      </p:sp>
+      <p:sp>
+        <p:nvSpPr>
+          <p:cNvPr id="7" name="Rounded Rectangle 6"/>
+          <p:cNvSpPr/>
+          <p:nvPr/>
+        </p:nvSpPr>
+        <p:spPr>
+          <a:xfrm>
+            <a:off x="4434840" y="1828800"/>
+            <a:ext cx="3246120" cy="1417320"/>
+          </a:xfrm>
+          <a:prstGeom prst="roundRect">
+            <a:avLst/>
+          </a:prstGeom>
+          <a:solidFill>
+            <a:srgbClr val="E4EDFD"/>
+          </a:solidFill>
+          <a:ln w="12700">
+            <a:solidFill>
+              <a:srgbClr val="0F62FE"/>
+            </a:solidFill>
+          </a:ln>
+          <a:effectLst/>
+        </p:spPr>
+        <p:style>
+          <a:lnRef idx="1">
+            <a:schemeClr val="accent1"/>
+          </a:lnRef>
+          <a:fillRef idx="3">
+            <a:schemeClr val="accent1"/>
+          </a:fillRef>
+          <a:effectRef idx="2">
+            <a:schemeClr val="accent1"/>
+          </a:effectRef>
+          <a:fontRef idx="minor">
+            <a:schemeClr val="lt1"/>
+          </a:fontRef>
+        </p:style>
+        <p:txBody>
+          <a:bodyPr rtlCol="0" anchor="ctr" wrap="square" lIns="73152" rIns="73152" tIns="36576" bIns="36576"/>
+          <a:lstStyle/>
+          <a:p>
+            <a:pPr algn="ctr">
+              <a:spcAft>
+                <a:spcPts val="0"/>
+              </a:spcAft>
+            </a:pPr>
+            <a:r>
+              <a:rPr sz="1400" b="1">
+                <a:solidFill>
+                  <a:srgbClr val="0F62FE"/>
+                </a:solidFill>
+                <a:latin typeface="Verdana"/>
+              </a:rPr>
+              <a:t>2. TEST</a:t>
+            </a:r>
+          </a:p>
+          <a:p>
+            <a:pPr algn="ctr">
+              <a:spcAft>
+                <a:spcPts val="0"/>
+              </a:spcAft>
+            </a:pPr>
+            <a:r>
+              <a:rPr sz="1200" b="0">
+                <a:solidFill>
+                  <a:srgbClr val="5B667A"/>
+                </a:solidFill>
+                <a:latin typeface="Verdana"/>
+              </a:rPr>
+              <a:t>Identity check against the shipped score,</a:t>
+            </a:r>
+          </a:p>
+          <a:p>
+            <a:pPr algn="ctr">
+              <a:spcAft>
+                <a:spcPts val="0"/>
+              </a:spcAft>
+            </a:pPr>
+            <a:r>
+              <a:rPr sz="1200" b="0">
+                <a:solidFill>
+                  <a:srgbClr val="5B667A"/>
+                </a:solidFill>
+                <a:latin typeface="Verdana"/>
+              </a:rPr>
+              <a:t>then a 200-sample A/B — never trust the delta alone</a:t>
+            </a:r>
+          </a:p>
+        </p:txBody>
+      </p:sp>
+      <p:sp>
+        <p:nvSpPr>
+          <p:cNvPr id="8" name="Right Arrow 7"/>
+          <p:cNvSpPr/>
+          <p:nvPr/>
+        </p:nvSpPr>
+        <p:spPr>
+          <a:xfrm>
+            <a:off x="7726680" y="2414016"/>
+            <a:ext cx="411480" cy="201168"/>
+          </a:xfrm>
+          <a:prstGeom prst="rightArrow">
+            <a:avLst/>
+          </a:prstGeom>
+          <a:solidFill>
+            <a:srgbClr val="0F62FE"/>
+          </a:solidFill>
+          <a:ln>
+            <a:noFill/>
+          </a:ln>
+          <a:effectLst/>
+        </p:spPr>
+        <p:style>
+          <a:lnRef idx="1">
+            <a:schemeClr val="accent1"/>
+          </a:lnRef>
+          <a:fillRef idx="3">
+            <a:schemeClr val="accent1"/>
+          </a:fillRef>
+          <a:effectRef idx="2">
+            <a:schemeClr val="accent1"/>
+          </a:effectRef>
+          <a:fontRef idx="minor">
+            <a:schemeClr val="lt1"/>
+          </a:fontRef>
+        </p:style>
+        <p:txBody>
+          <a:bodyPr rtlCol="0" anchor="ctr"/>
+          <a:lstStyle/>
+          <a:p>
+            <a:pPr algn="ctr"/>
+          </a:p>
+        </p:txBody>
+      </p:sp>
+      <p:sp>
+        <p:nvSpPr>
+          <p:cNvPr id="9" name="Rounded Rectangle 8"/>
+          <p:cNvSpPr/>
+          <p:nvPr/>
+        </p:nvSpPr>
+        <p:spPr>
+          <a:xfrm>
+            <a:off x="8183880" y="1828800"/>
+            <a:ext cx="3246120" cy="1417320"/>
+          </a:xfrm>
+          <a:prstGeom prst="roundRect">
+            <a:avLst/>
+          </a:prstGeom>
+          <a:solidFill>
+            <a:srgbClr val="F4F6FA"/>
+          </a:solidFill>
+          <a:ln w="12700">
+            <a:solidFill>
+              <a:srgbClr val="D8DDE6"/>
+            </a:solidFill>
+          </a:ln>
+          <a:effectLst/>
+        </p:spPr>
+        <p:style>
+          <a:lnRef idx="1">
+            <a:schemeClr val="accent1"/>
+          </a:lnRef>
+          <a:fillRef idx="3">
+            <a:schemeClr val="accent1"/>
+          </a:fillRef>
+          <a:effectRef idx="2">
+            <a:schemeClr val="accent1"/>
+          </a:effectRef>
+          <a:fontRef idx="minor">
+            <a:schemeClr val="lt1"/>
+          </a:fontRef>
+        </p:style>
+        <p:txBody>
+          <a:bodyPr rtlCol="0" anchor="ctr" wrap="square" lIns="73152" rIns="73152" tIns="36576" bIns="36576"/>
+          <a:lstStyle/>
+          <a:p>
+            <a:pPr algn="ctr">
+              <a:spcAft>
+                <a:spcPts val="0"/>
+              </a:spcAft>
+            </a:pPr>
+            <a:r>
+              <a:rPr sz="1400" b="1">
+                <a:solidFill>
+                  <a:srgbClr val="141B2D"/>
+                </a:solidFill>
+                <a:latin typeface="Verdana"/>
+              </a:rPr>
+              <a:t>3. COMMIT</a:t>
+            </a:r>
+          </a:p>
+          <a:p>
+            <a:pPr algn="ctr">
+              <a:spcAft>
+                <a:spcPts val="0"/>
+              </a:spcAft>
+            </a:pPr>
+            <a:r>
+              <a:rPr sz="1200" b="0">
+                <a:solidFill>
+                  <a:srgbClr val="5B667A"/>
+                </a:solidFill>
+                <a:latin typeface="Verdana"/>
+              </a:rPr>
+              <a:t>Ships if it wins the A/B;</a:t>
+            </a:r>
+          </a:p>
+          <a:p>
+            <a:pPr algn="ctr">
+              <a:spcAft>
+                <a:spcPts val="0"/>
+              </a:spcAft>
+            </a:pPr>
+            <a:r>
+              <a:rPr sz="1200" b="0">
+                <a:solidFill>
+                  <a:srgbClr val="5B667A"/>
+                </a:solidFill>
+                <a:latin typeface="Verdana"/>
+              </a:rPr>
+              <a:t>otherwise recorded on the ledger, not silently dropped</a:t>
+            </a:r>
+          </a:p>
+        </p:txBody>
+      </p:sp>
+      <p:sp>
+        <p:nvSpPr>
+          <p:cNvPr id="10" name="Left Arrow 9"/>
+          <p:cNvSpPr/>
+          <p:nvPr/>
+        </p:nvSpPr>
+        <p:spPr>
+          <a:xfrm>
+            <a:off x="685800" y="3520440"/>
+            <a:ext cx="10469880" cy="310896"/>
+          </a:xfrm>
+          <a:prstGeom prst="leftArrow">
+            <a:avLst/>
+          </a:prstGeom>
+          <a:solidFill>
+            <a:srgbClr val="E4EDFD"/>
+          </a:solidFill>
+          <a:ln w="9525">
+            <a:solidFill>
+              <a:srgbClr val="0F62FE"/>
+            </a:solidFill>
+          </a:ln>
+          <a:effectLst/>
+        </p:spPr>
+        <p:style>
+          <a:lnRef idx="1">
+            <a:schemeClr val="accent1"/>
+          </a:lnRef>
+          <a:fillRef idx="3">
+            <a:schemeClr val="accent1"/>
+          </a:fillRef>
+          <a:effectRef idx="2">
+            <a:schemeClr val="accent1"/>
+          </a:effectRef>
+          <a:fontRef idx="minor">
+            <a:schemeClr val="lt1"/>
+          </a:fontRef>
+        </p:style>
+        <p:txBody>
+          <a:bodyPr rtlCol="0" anchor="ctr"/>
+          <a:lstStyle/>
+          <a:p>
+            <a:pPr algn="ctr"/>
+            <a:r>
+              <a:rPr sz="1100" b="1">
+                <a:solidFill>
+                  <a:srgbClr val="0F62FE"/>
+                </a:solidFill>
+                <a:latin typeface="Verdana"/>
+              </a:rPr>
+              <a:t>a losing idea still becomes the next one — every ledger entry fed a later hypothesis</a:t>
+            </a:r>
+          </a:p>
+        </p:txBody>
+      </p:sp>
+      <p:graphicFrame>
+        <p:nvGraphicFramePr>
+          <p:cNvPr id="11" name="Table 10"/>
+          <p:cNvGraphicFramePr>
+            <a:graphicFrameLocks noGrp="1"/>
+          </p:cNvGraphicFramePr>
+          <p:nvPr/>
+        </p:nvGraphicFramePr>
+        <p:xfrm>
+          <a:off x="640080" y="4160520"/>
+          <a:ext cx="10908791" cy="2029968"/>
+        </p:xfrm>
+        <a:graphic>
+          <a:graphicData uri="http://schemas.openxmlformats.org/drawingml/2006/table">
+            <a:tbl>
+              <a:tblPr firstRow="1">
+                <a:tableStyleId>{5C22544A-7EE6-4342-B048-85BDC9FD1C3A}</a:tableStyleId>
+              </a:tblPr>
+              <a:tblGrid>
+                <a:gridCol w="1305325"/>
+                <a:gridCol w="6433390"/>
+                <a:gridCol w="3170076"/>
+              </a:tblGrid>
+              <a:tr h="329184">
+                <a:tc>
+                  <a:txBody>
+                    <a:bodyPr/>
+                    <a:lstStyle/>
+                    <a:p>
+                      <a:r>
+                        <a:rPr sz="1100" b="1">
+                          <a:solidFill>
+                            <a:srgbClr val="FFFFFF"/>
+                          </a:solidFill>
+                          <a:latin typeface="Verdana"/>
+                        </a:rPr>
+                        <a:t>Stage</a:t>
+                      </a:r>
+                    </a:p>
+                  </a:txBody>
+                  <a:tcPr marL="82296" marR="82296" marT="36576" marB="36576" anchor="ctr">
+                    <a:solidFill>
+                      <a:srgbClr val="141B2D"/>
+                    </a:solidFill>
+                  </a:tcPr>
+                </a:tc>
+                <a:tc>
+                  <a:txBody>
+                    <a:bodyPr/>
+                    <a:lstStyle/>
+                    <a:p>
+                      <a:r>
+                        <a:rPr sz="1100" b="1">
+                          <a:solidFill>
+                            <a:srgbClr val="FFFFFF"/>
+                          </a:solidFill>
+                          <a:latin typeface="Verdana"/>
+                        </a:rPr>
+                        <a:t>In practice on this repo</a:t>
+                      </a:r>
+                    </a:p>
+                  </a:txBody>
+                  <a:tcPr marL="82296" marR="82296" marT="36576" marB="36576" anchor="ctr">
+                    <a:solidFill>
+                      <a:srgbClr val="141B2D"/>
+                    </a:solidFill>
+                  </a:tcPr>
+                </a:tc>
+                <a:tc>
+                  <a:txBody>
+                    <a:bodyPr/>
+                    <a:lstStyle/>
+                    <a:p>
+                      <a:r>
+                        <a:rPr sz="1100" b="1">
+                          <a:solidFill>
+                            <a:srgbClr val="FFFFFF"/>
+                          </a:solidFill>
+                          <a:latin typeface="Verdana"/>
+                        </a:rPr>
+                        <a:t>Tooling</a:t>
+                      </a:r>
+                    </a:p>
+                  </a:txBody>
+                  <a:tcPr marL="82296" marR="82296" marT="36576" marB="36576" anchor="ctr">
+                    <a:solidFill>
+                      <a:srgbClr val="141B2D"/>
+                    </a:solidFill>
+                  </a:tcPr>
+                </a:tc>
+              </a:tr>
+              <a:tr h="566928">
+                <a:tc>
+                  <a:txBody>
+                    <a:bodyPr wrap="square"/>
+                    <a:lstStyle/>
+                    <a:p>
+                      <a:r>
+                        <a:rPr sz="1100" b="0">
+                          <a:solidFill>
+                            <a:srgbClr val="141B2D"/>
+                          </a:solidFill>
+                          <a:latin typeface="Verdana"/>
+                        </a:rPr>
+                        <a:t>Generate idea</a:t>
+                      </a:r>
+                    </a:p>
+                  </a:txBody>
+                  <a:tcPr marL="82296" marR="82296" marT="36576" marB="36576" anchor="ctr">
+                    <a:solidFill>
+                      <a:srgbClr val="FFFFFF"/>
+                    </a:solidFill>
+                  </a:tcPr>
+                </a:tc>
+                <a:tc>
+                  <a:txBody>
+                    <a:bodyPr wrap="square"/>
+                    <a:lstStyle/>
+                    <a:p>
+                      <a:r>
+                        <a:rPr sz="1100" b="0">
+                          <a:solidFill>
+                            <a:srgbClr val="141B2D"/>
+                          </a:solidFill>
+                          <a:latin typeface="Verdana"/>
+                        </a:rPr>
+                        <a:t>Read where the scorer disagrees with the target, or where a rejection pointed. Every idea started from a specific miss, not a general intuition.</a:t>
+                      </a:r>
+                    </a:p>
+                  </a:txBody>
+                  <a:tcPr marL="82296" marR="82296" marT="36576" marB="36576" anchor="ctr">
+                    <a:solidFill>
+                      <a:srgbClr val="FFFFFF"/>
+                    </a:solidFill>
+                  </a:tcPr>
+                </a:tc>
+                <a:tc>
+                  <a:txBody>
+                    <a:bodyPr wrap="square"/>
+                    <a:lstStyle/>
+                    <a:p>
+                      <a:r>
+                        <a:rPr sz="1100" b="0">
+                          <a:solidFill>
+                            <a:srgbClr val="141B2D"/>
+                          </a:solidFill>
+                          <a:latin typeface="Verdana"/>
+                        </a:rPr>
+                        <a:t>docs/team_report.md miss census</a:t>
+                      </a:r>
+                    </a:p>
+                  </a:txBody>
+                  <a:tcPr marL="82296" marR="82296" marT="36576" marB="36576" anchor="ctr">
+                    <a:solidFill>
+                      <a:srgbClr val="FFFFFF"/>
+                    </a:solidFill>
+                  </a:tcPr>
+                </a:tc>
+              </a:tr>
+              <a:tr h="566928">
+                <a:tc>
+                  <a:txBody>
+                    <a:bodyPr wrap="square"/>
+                    <a:lstStyle/>
+                    <a:p>
+                      <a:r>
+                        <a:rPr sz="1100" b="0">
+                          <a:solidFill>
+                            <a:srgbClr val="141B2D"/>
+                          </a:solidFill>
+                          <a:latin typeface="Verdana"/>
+                        </a:rPr>
+                        <a:t>Test</a:t>
+                      </a:r>
+                    </a:p>
+                  </a:txBody>
+                  <a:tcPr marL="82296" marR="82296" marT="36576" marB="36576" anchor="ctr">
+                    <a:solidFill>
+                      <a:srgbClr val="F4F6FA"/>
+                    </a:solidFill>
+                  </a:tcPr>
+                </a:tc>
+                <a:tc>
+                  <a:txBody>
+                    <a:bodyPr wrap="square"/>
+                    <a:lstStyle/>
+                    <a:p>
+                      <a:r>
+                        <a:rPr sz="1100" b="0">
+                          <a:solidFill>
+                            <a:srgbClr val="141B2D"/>
+                          </a:solidFill>
+                          <a:latin typeface="Verdana"/>
+                        </a:rPr>
+                        <a:t>A sweep script prints the identity row first and is checked against the shipped score before any other row is read; deltas under ±0.0025 on 200 samples are noise, not a result.</a:t>
+                      </a:r>
+                    </a:p>
+                  </a:txBody>
+                  <a:tcPr marL="82296" marR="82296" marT="36576" marB="36576" anchor="ctr">
+                    <a:solidFill>
+                      <a:srgbClr val="F4F6FA"/>
+                    </a:solidFill>
+                  </a:tcPr>
+                </a:tc>
+                <a:tc>
+                  <a:txBody>
+                    <a:bodyPr wrap="square"/>
+                    <a:lstStyle/>
+                    <a:p>
+                      <a:r>
+                        <a:rPr sz="1100" b="0">
+                          <a:solidFill>
+                            <a:srgbClr val="141B2D"/>
+                          </a:solidFill>
+                          <a:latin typeface="Verdana"/>
+                        </a:rPr>
+                        <a:t>scripts/sweep_*.py, scripts/eval_*.py</a:t>
+                      </a:r>
+                    </a:p>
+                  </a:txBody>
+                  <a:tcPr marL="82296" marR="82296" marT="36576" marB="36576" anchor="ctr">
+                    <a:solidFill>
+                      <a:srgbClr val="F4F6FA"/>
+                    </a:solidFill>
+                  </a:tcPr>
+                </a:tc>
+              </a:tr>
+              <a:tr h="566928">
+                <a:tc>
+                  <a:txBody>
+                    <a:bodyPr wrap="square"/>
+                    <a:lstStyle/>
+                    <a:p>
+                      <a:r>
+                        <a:rPr sz="1100" b="0">
+                          <a:solidFill>
+                            <a:srgbClr val="141B2D"/>
+                          </a:solidFill>
+                          <a:latin typeface="Verdana"/>
+                        </a:rPr>
+                        <a:t>Commit</a:t>
+                      </a:r>
+                    </a:p>
+                  </a:txBody>
+                  <a:tcPr marL="82296" marR="82296" marT="36576" marB="36576" anchor="ctr">
+                    <a:solidFill>
+                      <a:srgbClr val="FFFFFF"/>
+                    </a:solidFill>
+                  </a:tcPr>
+                </a:tc>
+                <a:tc>
+                  <a:txBody>
+                    <a:bodyPr wrap="square"/>
+                    <a:lstStyle/>
+                    <a:p>
+                      <a:r>
+                        <a:rPr sz="1100" b="0">
+                          <a:solidFill>
+                            <a:srgbClr val="141B2D"/>
+                          </a:solidFill>
+                          <a:latin typeface="Verdana"/>
+                        </a:rPr>
+                        <a:t>A win ships as one commit naming the measured number. A loss still gets committed — as a ledger entry recording what was expected and what happened, so the same idea is never re-tried blind.</a:t>
+                      </a:r>
+                    </a:p>
+                  </a:txBody>
+                  <a:tcPr marL="82296" marR="82296" marT="36576" marB="36576" anchor="ctr">
+                    <a:solidFill>
+                      <a:srgbClr val="FFFFFF"/>
+                    </a:solidFill>
+                  </a:tcPr>
+                </a:tc>
+                <a:tc>
+                  <a:txBody>
+                    <a:bodyPr wrap="square"/>
+                    <a:lstStyle/>
+                    <a:p>
+                      <a:r>
+                        <a:rPr sz="1100" b="0">
+                          <a:solidFill>
+                            <a:srgbClr val="141B2D"/>
+                          </a:solidFill>
+                          <a:latin typeface="Verdana"/>
+                        </a:rPr>
+                        <a:t>git log, the NEGATIVE RESULTS slide</a:t>
+                      </a:r>
+                    </a:p>
+                  </a:txBody>
+                  <a:tcPr marL="82296" marR="82296" marT="36576" marB="36576" anchor="ctr">
+                    <a:solidFill>
+                      <a:srgbClr val="FFFFFF"/>
+                    </a:solidFill>
+                  </a:tcPr>
+                </a:tc>
+              </a:tr>
+            </a:tbl>
+          </a:graphicData>
+        </a:graphic>
+      </p:graphicFrame>
+      <p:sp>
+        <p:nvSpPr>
+          <p:cNvPr id="12" name="TextBox 11"/>
+          <p:cNvSpPr txBox="1"/>
+          <p:nvPr/>
+        </p:nvSpPr>
+        <p:spPr>
+          <a:xfrm>
+            <a:off x="640080" y="6309360"/>
+            <a:ext cx="10881360" cy="457200"/>
+          </a:xfrm>
+          <a:prstGeom prst="rect">
+            <a:avLst/>
+          </a:prstGeom>
+          <a:noFill/>
+        </p:spPr>
+        <p:txBody>
+          <a:bodyPr wrap="square" lIns="0" rIns="0" tIns="0" bIns="0">
+            <a:spAutoFit/>
+          </a:bodyPr>
+          <a:lstStyle/>
+          <a:p>
+            <a:r>
+              <a:rPr sz="1300" b="1">
+                <a:solidFill>
+                  <a:srgbClr val="0F62FE"/>
+                </a:solidFill>
+                <a:latin typeface="Verdana"/>
+              </a:rPr>
+              <a:t>This is also why the deck has a NEGATIVE RESULTS slide: on this project, a rejected idea is still a shipped result.</a:t>
+            </a:r>
+          </a:p>
+        </p:txBody>
+      </p:sp>
+    </p:spTree>
+  </p:cSld>
+  <p:clrMapOvr>
+    <a:masterClrMapping/>
+  </p:clrMapOvr>
+</p:sld>
+</file>
+
+<file path=ppt/slides/slide2.xml><?xml version="1.0" encoding="utf-8"?>
+<p:sld xmlns:a="http://schemas.openxmlformats.org/drawingml/2006/main" xmlns:p="http://schemas.openxmlformats.org/presentationml/2006/main" xmlns:r="http://schemas.openxmlformats.org/officeDocument/2006/relationships">
+  <p:cSld>
+    <p:spTree>
+      <p:nvGrpSpPr>
+        <p:cNvPr id="1" name=""/>
+        <p:cNvGrpSpPr/>
+        <p:nvPr/>
+      </p:nvGrpSpPr>
+      <p:grpSpPr/>
+      <p:sp>
+        <p:nvSpPr>
+          <p:cNvPr id="2" name="TextBox 1"/>
+          <p:cNvSpPr txBox="1"/>
+          <p:nvPr/>
+        </p:nvSpPr>
+        <p:spPr>
+          <a:xfrm>
+            <a:off x="640080" y="384048"/>
+            <a:ext cx="10881360" cy="274320"/>
+          </a:xfrm>
+          <a:prstGeom prst="rect">
+            <a:avLst/>
+          </a:prstGeom>
+          <a:noFill/>
+        </p:spPr>
+        <p:txBody>
+          <a:bodyPr wrap="square" lIns="0" rIns="0" tIns="0" bIns="0">
+            <a:spAutoFit/>
+          </a:bodyPr>
+          <a:lstStyle/>
+          <a:p>
+            <a:pPr>
+              <a:spcAft>
+                <a:spcPts val="0"/>
+              </a:spcAft>
+            </a:pPr>
+            <a:r>
+              <a:rPr sz="1100" b="1">
+                <a:solidFill>
+                  <a:srgbClr val="0F62FE"/>
+                </a:solidFill>
+                <a:latin typeface="Verdana"/>
+              </a:rPr>
+              <a:t>PROBLEM</a:t>
+            </a:r>
+          </a:p>
+        </p:txBody>
+      </p:sp>
+      <p:sp>
+        <p:nvSpPr>
+          <p:cNvPr id="3" name="TextBox 2"/>
+          <p:cNvSpPr txBox="1"/>
+          <p:nvPr/>
+        </p:nvSpPr>
+        <p:spPr>
+          <a:xfrm>
+            <a:off x="640080" y="658368"/>
+            <a:ext cx="10881360" cy="685800"/>
+          </a:xfrm>
+          <a:prstGeom prst="rect">
+            <a:avLst/>
+          </a:prstGeom>
+          <a:noFill/>
+        </p:spPr>
+        <p:txBody>
+          <a:bodyPr wrap="square" lIns="0" rIns="0" tIns="0" bIns="0">
+            <a:spAutoFit/>
+          </a:bodyPr>
+          <a:lstStyle/>
+          <a:p>
+            <a:r>
+              <a:rPr sz="2800" b="1">
+                <a:solidFill>
+                  <a:srgbClr val="141B2D"/>
+                </a:solidFill>
+                <a:latin typeface="Georgia"/>
+              </a:rPr>
+              <a:t>The task</a:t>
+            </a:r>
+          </a:p>
+        </p:txBody>
+      </p:sp>
+      <p:sp>
+        <p:nvSpPr>
+          <p:cNvPr id="4" name="Rectangle 3"/>
+          <p:cNvSpPr/>
+          <p:nvPr/>
+        </p:nvSpPr>
+        <p:spPr>
+          <a:xfrm>
+            <a:off x="640080" y="1389888"/>
+            <a:ext cx="10908792" cy="9525"/>
+          </a:xfrm>
+          <a:prstGeom prst="rect">
+            <a:avLst/>
+          </a:prstGeom>
+          <a:solidFill>
+            <a:srgbClr val="D8DDE6"/>
+          </a:solidFill>
+          <a:ln>
+            <a:noFill/>
+          </a:ln>
+          <a:effectLst/>
+        </p:spPr>
+        <p:style>
+          <a:lnRef idx="1">
+            <a:schemeClr val="accent1"/>
+          </a:lnRef>
+          <a:fillRef idx="3">
+            <a:schemeClr val="accent1"/>
+          </a:fillRef>
+          <a:effectRef idx="2">
+            <a:schemeClr val="accent1"/>
+          </a:effectRef>
+          <a:fontRef idx="minor">
+            <a:schemeClr val="lt1"/>
+          </a:fontRef>
+        </p:style>
+        <p:txBody>
+          <a:bodyPr rtlCol="0" anchor="ctr"/>
+          <a:lstStyle/>
+          <a:p>
+            <a:pPr algn="ctr"/>
+          </a:p>
+        </p:txBody>
+      </p:sp>
+      <p:sp>
+        <p:nvSpPr>
+          <p:cNvPr id="5" name="Rounded Rectangle 4"/>
+          <p:cNvSpPr/>
+          <p:nvPr/>
+        </p:nvSpPr>
+        <p:spPr>
+          <a:xfrm>
+            <a:off x="822960" y="1828800"/>
+            <a:ext cx="2834640" cy="1051560"/>
+          </a:xfrm>
+          <a:prstGeom prst="roundRect">
+            <a:avLst/>
+          </a:prstGeom>
+          <a:solidFill>
+            <a:srgbClr val="F4F6FA"/>
+          </a:solidFill>
+          <a:ln w="12700">
+            <a:solidFill>
+              <a:srgbClr val="D8DDE6"/>
+            </a:solidFill>
+          </a:ln>
+          <a:effectLst/>
+        </p:spPr>
+        <p:style>
+          <a:lnRef idx="1">
+            <a:schemeClr val="accent1"/>
+          </a:lnRef>
+          <a:fillRef idx="3">
+            <a:schemeClr val="accent1"/>
+          </a:fillRef>
+          <a:effectRef idx="2">
+            <a:schemeClr val="accent1"/>
+          </a:effectRef>
+          <a:fontRef idx="minor">
+            <a:schemeClr val="lt1"/>
+          </a:fontRef>
+        </p:style>
+        <p:txBody>
+          <a:bodyPr rtlCol="0" anchor="ctr" wrap="square" lIns="73152" rIns="73152" tIns="36576" bIns="36576"/>
+          <a:lstStyle/>
+          <a:p>
+            <a:pPr algn="ctr">
+              <a:spcAft>
+                <a:spcPts val="0"/>
+              </a:spcAft>
+            </a:pPr>
+            <a:r>
+              <a:rPr sz="1500" b="1">
+                <a:solidFill>
+                  <a:srgbClr val="141B2D"/>
+                </a:solidFill>
+                <a:latin typeface="Verdana"/>
+              </a:rPr>
+              <a:t>Shopper speaks</a:t>
+            </a:r>
+          </a:p>
+          <a:p>
+            <a:pPr algn="ctr">
+              <a:spcAft>
+                <a:spcPts val="0"/>
+              </a:spcAft>
+            </a:pPr>
+            <a:r>
+              <a:rPr sz="1200" b="0">
+                <a:solidFill>
+                  <a:srgbClr val="5B667A"/>
+                </a:solidFill>
+                <a:latin typeface="Verdana"/>
+              </a:rPr>
+              <a:t>one hidden target,</a:t>
+            </a:r>
+          </a:p>
+          <a:p>
+            <a:pPr algn="ctr">
+              <a:spcAft>
+                <a:spcPts val="0"/>
+              </a:spcAft>
+            </a:pPr>
+            <a:r>
+              <a:rPr sz="1200" b="0">
+                <a:solidFill>
+                  <a:srgbClr val="5B667A"/>
+                </a:solidFill>
+                <a:latin typeface="Verdana"/>
+              </a:rPr>
+              <a:t>never named</a:t>
+            </a:r>
+          </a:p>
+        </p:txBody>
+      </p:sp>
+      <p:sp>
+        <p:nvSpPr>
+          <p:cNvPr id="6" name="Right Arrow 5"/>
+          <p:cNvSpPr/>
+          <p:nvPr/>
+        </p:nvSpPr>
+        <p:spPr>
+          <a:xfrm>
+            <a:off x="3749040" y="2267712"/>
+            <a:ext cx="457200" cy="201168"/>
+          </a:xfrm>
+          <a:prstGeom prst="rightArrow">
+            <a:avLst/>
+          </a:prstGeom>
+          <a:solidFill>
+            <a:srgbClr val="0F62FE"/>
+          </a:solidFill>
+          <a:ln>
+            <a:noFill/>
+          </a:ln>
+          <a:effectLst/>
+        </p:spPr>
+        <p:style>
+          <a:lnRef idx="1">
+            <a:schemeClr val="accent1"/>
+          </a:lnRef>
+          <a:fillRef idx="3">
+            <a:schemeClr val="accent1"/>
+          </a:fillRef>
+          <a:effectRef idx="2">
+            <a:schemeClr val="accent1"/>
+          </a:effectRef>
+          <a:fontRef idx="minor">
+            <a:schemeClr val="lt1"/>
+          </a:fontRef>
+        </p:style>
+        <p:txBody>
+          <a:bodyPr rtlCol="0" anchor="ctr"/>
+          <a:lstStyle/>
+          <a:p>
+            <a:pPr algn="ctr"/>
+          </a:p>
+        </p:txBody>
+      </p:sp>
+      <p:sp>
+        <p:nvSpPr>
+          <p:cNvPr id="7" name="Rounded Rectangle 6"/>
+          <p:cNvSpPr/>
+          <p:nvPr/>
+        </p:nvSpPr>
+        <p:spPr>
+          <a:xfrm>
+            <a:off x="4206240" y="1828800"/>
+            <a:ext cx="2834640" cy="1051560"/>
+          </a:xfrm>
+          <a:prstGeom prst="roundRect">
+            <a:avLst/>
+          </a:prstGeom>
+          <a:solidFill>
+            <a:srgbClr val="E4EDFD"/>
+          </a:solidFill>
+          <a:ln w="12700">
+            <a:solidFill>
+              <a:srgbClr val="D8DDE6"/>
+            </a:solidFill>
+          </a:ln>
+          <a:effectLst/>
+        </p:spPr>
+        <p:style>
+          <a:lnRef idx="1">
+            <a:schemeClr val="accent1"/>
+          </a:lnRef>
+          <a:fillRef idx="3">
+            <a:schemeClr val="accent1"/>
+          </a:fillRef>
+          <a:effectRef idx="2">
+            <a:schemeClr val="accent1"/>
+          </a:effectRef>
+          <a:fontRef idx="minor">
+            <a:schemeClr val="lt1"/>
+          </a:fontRef>
+        </p:style>
+        <p:txBody>
+          <a:bodyPr rtlCol="0" anchor="ctr" wrap="square" lIns="73152" rIns="73152" tIns="36576" bIns="36576"/>
+          <a:lstStyle/>
+          <a:p>
+            <a:pPr algn="ctr">
+              <a:spcAft>
+                <a:spcPts val="0"/>
+              </a:spcAft>
+            </a:pPr>
+            <a:r>
+              <a:rPr sz="1500" b="1">
+                <a:solidFill>
+                  <a:srgbClr val="141B2D"/>
+                </a:solidFill>
+                <a:latin typeface="Verdana"/>
+              </a:rPr>
+              <a:t>We answer</a:t>
+            </a:r>
+          </a:p>
+          <a:p>
+            <a:pPr algn="ctr">
+              <a:spcAft>
+                <a:spcPts val="0"/>
+              </a:spcAft>
+            </a:pPr>
+            <a:r>
+              <a:rPr sz="1200" b="0">
+                <a:solidFill>
+                  <a:srgbClr val="5B667A"/>
+                </a:solidFill>
+                <a:latin typeface="Verdana"/>
+              </a:rPr>
+              <a:t>return 10 products</a:t>
+            </a:r>
+          </a:p>
+          <a:p>
+            <a:pPr algn="ctr">
+              <a:spcAft>
+                <a:spcPts val="0"/>
+              </a:spcAft>
+            </a:pPr>
+            <a:r>
+              <a:rPr sz="1200" b="0">
+                <a:solidFill>
+                  <a:srgbClr val="5B667A"/>
+                </a:solidFill>
+                <a:latin typeface="Verdana"/>
+              </a:rPr>
+              <a:t>+ ask 1 question</a:t>
+            </a:r>
+          </a:p>
+        </p:txBody>
+      </p:sp>
+      <p:sp>
+        <p:nvSpPr>
+          <p:cNvPr id="8" name="Right Arrow 7"/>
+          <p:cNvSpPr/>
+          <p:nvPr/>
+        </p:nvSpPr>
+        <p:spPr>
+          <a:xfrm>
+            <a:off x="7132320" y="2267712"/>
+            <a:ext cx="457200" cy="201168"/>
+          </a:xfrm>
+          <a:prstGeom prst="rightArrow">
+            <a:avLst/>
+          </a:prstGeom>
+          <a:solidFill>
+            <a:srgbClr val="0F62FE"/>
+          </a:solidFill>
+          <a:ln>
+            <a:noFill/>
+          </a:ln>
+          <a:effectLst/>
+        </p:spPr>
+        <p:style>
+          <a:lnRef idx="1">
+            <a:schemeClr val="accent1"/>
+          </a:lnRef>
+          <a:fillRef idx="3">
+            <a:schemeClr val="accent1"/>
+          </a:fillRef>
+          <a:effectRef idx="2">
+            <a:schemeClr val="accent1"/>
+          </a:effectRef>
+          <a:fontRef idx="minor">
+            <a:schemeClr val="lt1"/>
+          </a:fontRef>
+        </p:style>
+        <p:txBody>
+          <a:bodyPr rtlCol="0" anchor="ctr"/>
+          <a:lstStyle/>
+          <a:p>
+            <a:pPr algn="ctr"/>
+          </a:p>
+        </p:txBody>
+      </p:sp>
+      <p:sp>
+        <p:nvSpPr>
+          <p:cNvPr id="9" name="Rounded Rectangle 8"/>
+          <p:cNvSpPr/>
+          <p:nvPr/>
+        </p:nvSpPr>
+        <p:spPr>
+          <a:xfrm>
+            <a:off x="7589520" y="1828800"/>
+            <a:ext cx="2834640" cy="1051560"/>
+          </a:xfrm>
+          <a:prstGeom prst="roundRect">
+            <a:avLst/>
+          </a:prstGeom>
+          <a:solidFill>
+            <a:srgbClr val="F4F6FA"/>
+          </a:solidFill>
+          <a:ln w="12700">
+            <a:solidFill>
+              <a:srgbClr val="D8DDE6"/>
+            </a:solidFill>
+          </a:ln>
+          <a:effectLst/>
+        </p:spPr>
+        <p:style>
+          <a:lnRef idx="1">
+            <a:schemeClr val="accent1"/>
+          </a:lnRef>
+          <a:fillRef idx="3">
+            <a:schemeClr val="accent1"/>
+          </a:fillRef>
+          <a:effectRef idx="2">
+            <a:schemeClr val="accent1"/>
+          </a:effectRef>
+          <a:fontRef idx="minor">
+            <a:schemeClr val="lt1"/>
+          </a:fontRef>
+        </p:style>
+        <p:txBody>
+          <a:bodyPr rtlCol="0" anchor="ctr" wrap="square" lIns="73152" rIns="73152" tIns="36576" bIns="36576"/>
+          <a:lstStyle/>
+          <a:p>
+            <a:pPr algn="ctr">
+              <a:spcAft>
+                <a:spcPts val="0"/>
+              </a:spcAft>
+            </a:pPr>
+            <a:r>
+              <a:rPr sz="1500" b="1">
+                <a:solidFill>
+                  <a:srgbClr val="141B2D"/>
+                </a:solidFill>
+                <a:latin typeface="Verdana"/>
+              </a:rPr>
+              <a:t>Grader checks</a:t>
+            </a:r>
+          </a:p>
+          <a:p>
+            <a:pPr algn="ctr">
+              <a:spcAft>
+                <a:spcPts val="0"/>
+              </a:spcAft>
+            </a:pPr>
+            <a:r>
+              <a:rPr sz="1200" b="0">
+                <a:solidFill>
+                  <a:srgbClr val="5B667A"/>
+                </a:solidFill>
+                <a:latin typeface="Verdana"/>
+              </a:rPr>
+              <a:t>is the target</a:t>
+            </a:r>
+          </a:p>
+          <a:p>
+            <a:pPr algn="ctr">
+              <a:spcAft>
+                <a:spcPts val="0"/>
+              </a:spcAft>
+            </a:pPr>
+            <a:r>
+              <a:rPr sz="1200" b="0">
+                <a:solidFill>
+                  <a:srgbClr val="5B667A"/>
+                </a:solidFill>
+                <a:latin typeface="Verdana"/>
+              </a:rPr>
+              <a:t>in those 10?</a:t>
+            </a:r>
+          </a:p>
+        </p:txBody>
+      </p:sp>
+      <p:sp>
+        <p:nvSpPr>
+          <p:cNvPr id="10" name="Rounded Rectangle 9"/>
+          <p:cNvSpPr/>
+          <p:nvPr/>
+        </p:nvSpPr>
+        <p:spPr>
+          <a:xfrm>
+            <a:off x="10972800" y="1828800"/>
+            <a:ext cx="685800" cy="1051560"/>
+          </a:xfrm>
+          <a:prstGeom prst="roundRect">
+            <a:avLst/>
+          </a:prstGeom>
+          <a:solidFill>
+            <a:srgbClr val="E6F3EC"/>
+          </a:solidFill>
+          <a:ln w="12700">
+            <a:solidFill>
+              <a:srgbClr val="0B7A4B"/>
+            </a:solidFill>
+          </a:ln>
+          <a:effectLst/>
+        </p:spPr>
+        <p:style>
+          <a:lnRef idx="1">
+            <a:schemeClr val="accent1"/>
+          </a:lnRef>
+          <a:fillRef idx="3">
+            <a:schemeClr val="accent1"/>
+          </a:fillRef>
+          <a:effectRef idx="2">
+            <a:schemeClr val="accent1"/>
+          </a:effectRef>
+          <a:fontRef idx="minor">
+            <a:schemeClr val="lt1"/>
+          </a:fontRef>
+        </p:style>
+        <p:txBody>
+          <a:bodyPr rtlCol="0" anchor="ctr" wrap="square" lIns="73152" rIns="73152" tIns="36576" bIns="36576"/>
+          <a:lstStyle/>
+          <a:p>
+            <a:pPr algn="ctr">
+              <a:spcAft>
+                <a:spcPts val="0"/>
+              </a:spcAft>
+            </a:pPr>
+            <a:r>
+              <a:rPr sz="1300" b="1">
+                <a:solidFill>
+                  <a:srgbClr val="0B7A4B"/>
+                </a:solidFill>
+                <a:latin typeface="Verdana"/>
+              </a:rPr>
+              <a:t>HIT</a:t>
+            </a:r>
+          </a:p>
+          <a:p>
+            <a:pPr algn="ctr">
+              <a:spcAft>
+                <a:spcPts val="0"/>
+              </a:spcAft>
+            </a:pPr>
+            <a:r>
+              <a:rPr sz="1000" b="0">
+                <a:solidFill>
+                  <a:srgbClr val="5B667A"/>
+                </a:solidFill>
+                <a:latin typeface="Verdana"/>
+              </a:rPr>
+              <a:t>session ends</a:t>
+            </a:r>
+          </a:p>
+        </p:txBody>
+      </p:sp>
+      <p:sp>
+        <p:nvSpPr>
+          <p:cNvPr id="11" name="Left Arrow 10"/>
+          <p:cNvSpPr/>
+          <p:nvPr/>
+        </p:nvSpPr>
+        <p:spPr>
+          <a:xfrm>
+            <a:off x="822960" y="3154680"/>
+            <a:ext cx="9509760" cy="310896"/>
+          </a:xfrm>
+          <a:prstGeom prst="leftArrow">
+            <a:avLst/>
+          </a:prstGeom>
+          <a:solidFill>
+            <a:srgbClr val="E4EDFD"/>
+          </a:solidFill>
+          <a:ln w="9525">
+            <a:solidFill>
+              <a:srgbClr val="0F62FE"/>
+            </a:solidFill>
+          </a:ln>
+          <a:effectLst/>
+        </p:spPr>
+        <p:style>
+          <a:lnRef idx="1">
+            <a:schemeClr val="accent1"/>
+          </a:lnRef>
+          <a:fillRef idx="3">
+            <a:schemeClr val="accent1"/>
+          </a:fillRef>
+          <a:effectRef idx="2">
+            <a:schemeClr val="accent1"/>
+          </a:effectRef>
+          <a:fontRef idx="minor">
+            <a:schemeClr val="lt1"/>
+          </a:fontRef>
+        </p:style>
+        <p:txBody>
+          <a:bodyPr rtlCol="0" anchor="ctr"/>
+          <a:lstStyle/>
+          <a:p>
+            <a:pPr algn="ctr"/>
+            <a:r>
+              <a:rPr sz="1100" b="1">
+                <a:solidFill>
+                  <a:srgbClr val="0F62FE"/>
+                </a:solidFill>
+                <a:latin typeface="Verdana"/>
+              </a:rPr>
+              <a:t>miss  →  next turn, up to 10 of them</a:t>
+            </a:r>
+          </a:p>
+        </p:txBody>
+      </p:sp>
+      <p:graphicFrame>
+        <p:nvGraphicFramePr>
+          <p:cNvPr id="12" name="Table 11"/>
+          <p:cNvGraphicFramePr>
+            <a:graphicFrameLocks noGrp="1"/>
+          </p:cNvGraphicFramePr>
+          <p:nvPr/>
+        </p:nvGraphicFramePr>
+        <p:xfrm>
+          <a:off x="640080" y="3977639"/>
+          <a:ext cx="10908791" cy="1371600"/>
+        </p:xfrm>
+        <a:graphic>
+          <a:graphicData uri="http://schemas.openxmlformats.org/drawingml/2006/table">
+            <a:tbl>
+              <a:tblPr firstRow="1">
+                <a:tableStyleId>{5C22544A-7EE6-4342-B048-85BDC9FD1C3A}</a:tableStyleId>
+              </a:tblPr>
+              <a:tblGrid>
+                <a:gridCol w="2016751"/>
+                <a:gridCol w="1100046"/>
+                <a:gridCol w="7791994"/>
+              </a:tblGrid>
+              <a:tr h="329184">
+                <a:tc>
+                  <a:txBody>
+                    <a:bodyPr/>
+                    <a:lstStyle/>
+                    <a:p>
+                      <a:r>
+                        <a:rPr sz="1100" b="1">
+                          <a:solidFill>
+                            <a:srgbClr val="FFFFFF"/>
+                          </a:solidFill>
+                          <a:latin typeface="Verdana"/>
+                        </a:rPr>
+                        <a:t>Term</a:t>
+                      </a:r>
+                    </a:p>
+                  </a:txBody>
+                  <a:tcPr marL="82296" marR="82296" marT="36576" marB="36576" anchor="ctr">
+                    <a:solidFill>
+                      <a:srgbClr val="141B2D"/>
+                    </a:solidFill>
+                  </a:tcPr>
+                </a:tc>
+                <a:tc>
+                  <a:txBody>
+                    <a:bodyPr/>
+                    <a:lstStyle/>
+                    <a:p>
+                      <a:r>
+                        <a:rPr sz="1100" b="1">
+                          <a:solidFill>
+                            <a:srgbClr val="FFFFFF"/>
+                          </a:solidFill>
+                          <a:latin typeface="Verdana"/>
+                        </a:rPr>
+                        <a:t>Weight</a:t>
+                      </a:r>
+                    </a:p>
+                  </a:txBody>
+                  <a:tcPr marL="82296" marR="82296" marT="36576" marB="36576" anchor="ctr">
+                    <a:solidFill>
+                      <a:srgbClr val="141B2D"/>
+                    </a:solidFill>
+                  </a:tcPr>
+                </a:tc>
+                <a:tc>
+                  <a:txBody>
+                    <a:bodyPr/>
+                    <a:lstStyle/>
+                    <a:p>
+                      <a:r>
+                        <a:rPr sz="1100" b="1">
+                          <a:solidFill>
+                            <a:srgbClr val="FFFFFF"/>
+                          </a:solidFill>
+                          <a:latin typeface="Verdana"/>
+                        </a:rPr>
+                        <a:t>What it rewards</a:t>
+                      </a:r>
+                    </a:p>
+                  </a:txBody>
+                  <a:tcPr marL="82296" marR="82296" marT="36576" marB="36576" anchor="ctr">
+                    <a:solidFill>
+                      <a:srgbClr val="141B2D"/>
+                    </a:solidFill>
+                  </a:tcPr>
+                </a:tc>
+              </a:tr>
+              <a:tr h="347472">
+                <a:tc>
+                  <a:txBody>
+                    <a:bodyPr wrap="square"/>
+                    <a:lstStyle/>
+                    <a:p>
+                      <a:r>
+                        <a:rPr sz="1200" b="0">
+                          <a:solidFill>
+                            <a:srgbClr val="141B2D"/>
+                          </a:solidFill>
+                          <a:latin typeface="Verdana"/>
+                        </a:rPr>
+                        <a:t>HitRate@10</a:t>
+                      </a:r>
+                    </a:p>
+                  </a:txBody>
+                  <a:tcPr marL="82296" marR="82296" marT="36576" marB="36576" anchor="ctr">
+                    <a:solidFill>
+                      <a:srgbClr val="FFFFFF"/>
+                    </a:solidFill>
+                  </a:tcPr>
+                </a:tc>
+                <a:tc>
+                  <a:txBody>
+                    <a:bodyPr wrap="square"/>
+                    <a:lstStyle/>
+                    <a:p>
+                      <a:r>
+                        <a:rPr sz="1200" b="0">
+                          <a:solidFill>
+                            <a:srgbClr val="141B2D"/>
+                          </a:solidFill>
+                          <a:latin typeface="Verdana"/>
+                        </a:rPr>
+                        <a:t>0.50</a:t>
+                      </a:r>
+                    </a:p>
+                  </a:txBody>
+                  <a:tcPr marL="82296" marR="82296" marT="36576" marB="36576" anchor="ctr">
+                    <a:solidFill>
+                      <a:srgbClr val="FFFFFF"/>
+                    </a:solidFill>
+                  </a:tcPr>
+                </a:tc>
+                <a:tc>
+                  <a:txBody>
+                    <a:bodyPr wrap="square"/>
+                    <a:lstStyle/>
+                    <a:p>
+                      <a:r>
+                        <a:rPr sz="1200" b="0">
+                          <a:solidFill>
+                            <a:srgbClr val="141B2D"/>
+                          </a:solidFill>
+                          <a:latin typeface="Verdana"/>
+                        </a:rPr>
+                        <a:t>Finding the target at all, in any of the 10 slots.</a:t>
+                      </a:r>
+                    </a:p>
+                  </a:txBody>
+                  <a:tcPr marL="82296" marR="82296" marT="36576" marB="36576" anchor="ctr">
+                    <a:solidFill>
+                      <a:srgbClr val="FFFFFF"/>
+                    </a:solidFill>
+                  </a:tcPr>
+                </a:tc>
+              </a:tr>
+              <a:tr h="347472">
+                <a:tc>
+                  <a:txBody>
+                    <a:bodyPr wrap="square"/>
+                    <a:lstStyle/>
+                    <a:p>
+                      <a:r>
+                        <a:rPr sz="1200" b="0">
+                          <a:solidFill>
+                            <a:srgbClr val="141B2D"/>
+                          </a:solidFill>
+                          <a:latin typeface="Verdana"/>
+                        </a:rPr>
+                        <a:t>MRR</a:t>
+                      </a:r>
+                    </a:p>
+                  </a:txBody>
+                  <a:tcPr marL="82296" marR="82296" marT="36576" marB="36576" anchor="ctr">
+                    <a:solidFill>
+                      <a:srgbClr val="F4F6FA"/>
+                    </a:solidFill>
+                  </a:tcPr>
+                </a:tc>
+                <a:tc>
+                  <a:txBody>
+                    <a:bodyPr wrap="square"/>
+                    <a:lstStyle/>
+                    <a:p>
+                      <a:r>
+                        <a:rPr sz="1200" b="0">
+                          <a:solidFill>
+                            <a:srgbClr val="141B2D"/>
+                          </a:solidFill>
+                          <a:latin typeface="Verdana"/>
+                        </a:rPr>
+                        <a:t>0.30</a:t>
+                      </a:r>
+                    </a:p>
+                  </a:txBody>
+                  <a:tcPr marL="82296" marR="82296" marT="36576" marB="36576" anchor="ctr">
+                    <a:solidFill>
+                      <a:srgbClr val="F4F6FA"/>
+                    </a:solidFill>
+                  </a:tcPr>
+                </a:tc>
+                <a:tc>
+                  <a:txBody>
+                    <a:bodyPr wrap="square"/>
+                    <a:lstStyle/>
+                    <a:p>
+                      <a:r>
+                        <a:rPr sz="1200" b="1">
+                          <a:solidFill>
+                            <a:srgbClr val="0F62FE"/>
+                          </a:solidFill>
+                          <a:latin typeface="Verdana"/>
+                        </a:rPr>
+                        <a:t>Its rank at the FIRST hit — not the best rank we ever reached.</a:t>
+                      </a:r>
+                    </a:p>
+                  </a:txBody>
+                  <a:tcPr marL="82296" marR="82296" marT="36576" marB="36576" anchor="ctr">
+                    <a:solidFill>
+                      <a:srgbClr val="F4F6FA"/>
+                    </a:solidFill>
+                  </a:tcPr>
+                </a:tc>
+              </a:tr>
+              <a:tr h="347472">
+                <a:tc>
+                  <a:txBody>
+                    <a:bodyPr wrap="square"/>
+                    <a:lstStyle/>
+                    <a:p>
+                      <a:r>
+                        <a:rPr sz="1200" b="0">
+                          <a:solidFill>
+                            <a:srgbClr val="141B2D"/>
+                          </a:solidFill>
+                          <a:latin typeface="Verdana"/>
+                        </a:rPr>
+                        <a:t>Efficiency</a:t>
+                      </a:r>
+                    </a:p>
+                  </a:txBody>
+                  <a:tcPr marL="82296" marR="82296" marT="36576" marB="36576" anchor="ctr">
+                    <a:solidFill>
+                      <a:srgbClr val="FFFFFF"/>
+                    </a:solidFill>
+                  </a:tcPr>
+                </a:tc>
+                <a:tc>
+                  <a:txBody>
+                    <a:bodyPr wrap="square"/>
+                    <a:lstStyle/>
+                    <a:p>
+                      <a:r>
+                        <a:rPr sz="1200" b="0">
+                          <a:solidFill>
+                            <a:srgbClr val="141B2D"/>
+                          </a:solidFill>
+                          <a:latin typeface="Verdana"/>
+                        </a:rPr>
+                        <a:t>0.20</a:t>
+                      </a:r>
+                    </a:p>
+                  </a:txBody>
+                  <a:tcPr marL="82296" marR="82296" marT="36576" marB="36576" anchor="ctr">
+                    <a:solidFill>
+                      <a:srgbClr val="FFFFFF"/>
+                    </a:solidFill>
+                  </a:tcPr>
+                </a:tc>
+                <a:tc>
+                  <a:txBody>
+                    <a:bodyPr wrap="square"/>
+                    <a:lstStyle/>
+                    <a:p>
+                      <a:r>
+                        <a:rPr sz="1200" b="0">
+                          <a:solidFill>
+                            <a:srgbClr val="141B2D"/>
+                          </a:solidFill>
+                          <a:latin typeface="Verdana"/>
+                        </a:rPr>
+                        <a:t>Finding it in fewer turns. (11 − turns) / 10.</a:t>
+                      </a:r>
+                    </a:p>
+                  </a:txBody>
+                  <a:tcPr marL="82296" marR="82296" marT="36576" marB="36576" anchor="ctr">
+                    <a:solidFill>
+                      <a:srgbClr val="FFFFFF"/>
+                    </a:solidFill>
+                  </a:tcPr>
+                </a:tc>
+              </a:tr>
+            </a:tbl>
+          </a:graphicData>
+        </a:graphic>
+      </p:graphicFrame>
+      <p:sp>
+        <p:nvSpPr>
+          <p:cNvPr id="13" name="TextBox 12"/>
+          <p:cNvSpPr txBox="1"/>
+          <p:nvPr/>
+        </p:nvSpPr>
+        <p:spPr>
+          <a:xfrm>
+            <a:off x="640080" y="5623560"/>
+            <a:ext cx="10881360" cy="457200"/>
+          </a:xfrm>
+          <a:prstGeom prst="rect">
+            <a:avLst/>
+          </a:prstGeom>
+          <a:noFill/>
+        </p:spPr>
+        <p:txBody>
+          <a:bodyPr wrap="square" lIns="0" rIns="0" tIns="0" bIns="0">
+            <a:spAutoFit/>
+          </a:bodyPr>
+          <a:lstStyle/>
+          <a:p>
+            <a:r>
+              <a:rPr sz="1300" b="1">
+                <a:solidFill>
+                  <a:srgbClr val="0F62FE"/>
+                </a:solidFill>
+                <a:latin typeface="Verdana"/>
+              </a:rPr>
+              <a:t>Consequence we designed around: an earlier hit at a worse rank still pays. Speed beats polish.</a:t>
+            </a:r>
+          </a:p>
+        </p:txBody>
+      </p:sp>
+    </p:spTree>
+  </p:cSld>
+  <p:clrMapOvr>
+    <a:masterClrMapping/>
+  </p:clrMapOvr>
+</p:sld>
+</file>
+
+<file path=ppt/slides/slide20.xml><?xml version="1.0" encoding="utf-8"?>
 <p:sld xmlns:a="http://schemas.openxmlformats.org/drawingml/2006/main" xmlns:p="http://schemas.openxmlformats.org/presentationml/2006/main" xmlns:r="http://schemas.openxmlformats.org/officeDocument/2006/relationships">
   <p:cSld>
     <p:spTree>
@@ -11494,7 +14792,7 @@
 </p:sld>
 </file>
 
-<file path=ppt/slides/slide18.xml><?xml version="1.0" encoding="utf-8"?>
+<file path=ppt/slides/slide21.xml><?xml version="1.0" encoding="utf-8"?>
 <p:sld xmlns:a="http://schemas.openxmlformats.org/drawingml/2006/main" xmlns:p="http://schemas.openxmlformats.org/presentationml/2006/main" xmlns:r="http://schemas.openxmlformats.org/officeDocument/2006/relationships">
   <p:cSld>
     <p:spTree>
@@ -12141,7 +15439,7 @@
 </p:sld>
 </file>
 
-<file path=ppt/slides/slide19.xml><?xml version="1.0" encoding="utf-8"?>
+<file path=ppt/slides/slide22.xml><?xml version="1.0" encoding="utf-8"?>
 <p:sld xmlns:a="http://schemas.openxmlformats.org/drawingml/2006/main" xmlns:p="http://schemas.openxmlformats.org/presentationml/2006/main" xmlns:r="http://schemas.openxmlformats.org/officeDocument/2006/relationships">
   <p:cSld>
     <p:spTree>
@@ -12705,7 +16003,7 @@
 </p:sld>
 </file>
 
-<file path=ppt/slides/slide2.xml><?xml version="1.0" encoding="utf-8"?>
+<file path=ppt/slides/slide23.xml><?xml version="1.0" encoding="utf-8"?>
 <p:sld xmlns:a="http://schemas.openxmlformats.org/drawingml/2006/main" xmlns:p="http://schemas.openxmlformats.org/presentationml/2006/main" xmlns:r="http://schemas.openxmlformats.org/officeDocument/2006/relationships">
   <p:cSld>
     <p:spTree>
@@ -12749,965 +16047,6 @@
                 </a:solidFill>
                 <a:latin typeface="Verdana"/>
               </a:rPr>
-              <a:t>PROBLEM</a:t>
-            </a:r>
-          </a:p>
-        </p:txBody>
-      </p:sp>
-      <p:sp>
-        <p:nvSpPr>
-          <p:cNvPr id="3" name="TextBox 2"/>
-          <p:cNvSpPr txBox="1"/>
-          <p:nvPr/>
-        </p:nvSpPr>
-        <p:spPr>
-          <a:xfrm>
-            <a:off x="640080" y="658368"/>
-            <a:ext cx="10881360" cy="685800"/>
-          </a:xfrm>
-          <a:prstGeom prst="rect">
-            <a:avLst/>
-          </a:prstGeom>
-          <a:noFill/>
-        </p:spPr>
-        <p:txBody>
-          <a:bodyPr wrap="square" lIns="0" rIns="0" tIns="0" bIns="0">
-            <a:spAutoFit/>
-          </a:bodyPr>
-          <a:lstStyle/>
-          <a:p>
-            <a:r>
-              <a:rPr sz="2800" b="1">
-                <a:solidFill>
-                  <a:srgbClr val="141B2D"/>
-                </a:solidFill>
-                <a:latin typeface="Georgia"/>
-              </a:rPr>
-              <a:t>The task</a:t>
-            </a:r>
-          </a:p>
-        </p:txBody>
-      </p:sp>
-      <p:sp>
-        <p:nvSpPr>
-          <p:cNvPr id="4" name="Rectangle 3"/>
-          <p:cNvSpPr/>
-          <p:nvPr/>
-        </p:nvSpPr>
-        <p:spPr>
-          <a:xfrm>
-            <a:off x="640080" y="1389888"/>
-            <a:ext cx="10908792" cy="9525"/>
-          </a:xfrm>
-          <a:prstGeom prst="rect">
-            <a:avLst/>
-          </a:prstGeom>
-          <a:solidFill>
-            <a:srgbClr val="D8DDE6"/>
-          </a:solidFill>
-          <a:ln>
-            <a:noFill/>
-          </a:ln>
-          <a:effectLst/>
-        </p:spPr>
-        <p:style>
-          <a:lnRef idx="1">
-            <a:schemeClr val="accent1"/>
-          </a:lnRef>
-          <a:fillRef idx="3">
-            <a:schemeClr val="accent1"/>
-          </a:fillRef>
-          <a:effectRef idx="2">
-            <a:schemeClr val="accent1"/>
-          </a:effectRef>
-          <a:fontRef idx="minor">
-            <a:schemeClr val="lt1"/>
-          </a:fontRef>
-        </p:style>
-        <p:txBody>
-          <a:bodyPr rtlCol="0" anchor="ctr"/>
-          <a:lstStyle/>
-          <a:p>
-            <a:pPr algn="ctr"/>
-          </a:p>
-        </p:txBody>
-      </p:sp>
-      <p:sp>
-        <p:nvSpPr>
-          <p:cNvPr id="5" name="Rounded Rectangle 4"/>
-          <p:cNvSpPr/>
-          <p:nvPr/>
-        </p:nvSpPr>
-        <p:spPr>
-          <a:xfrm>
-            <a:off x="822960" y="1828800"/>
-            <a:ext cx="2834640" cy="1051560"/>
-          </a:xfrm>
-          <a:prstGeom prst="roundRect">
-            <a:avLst/>
-          </a:prstGeom>
-          <a:solidFill>
-            <a:srgbClr val="F4F6FA"/>
-          </a:solidFill>
-          <a:ln w="12700">
-            <a:solidFill>
-              <a:srgbClr val="D8DDE6"/>
-            </a:solidFill>
-          </a:ln>
-          <a:effectLst/>
-        </p:spPr>
-        <p:style>
-          <a:lnRef idx="1">
-            <a:schemeClr val="accent1"/>
-          </a:lnRef>
-          <a:fillRef idx="3">
-            <a:schemeClr val="accent1"/>
-          </a:fillRef>
-          <a:effectRef idx="2">
-            <a:schemeClr val="accent1"/>
-          </a:effectRef>
-          <a:fontRef idx="minor">
-            <a:schemeClr val="lt1"/>
-          </a:fontRef>
-        </p:style>
-        <p:txBody>
-          <a:bodyPr rtlCol="0" anchor="ctr" wrap="square" lIns="73152" rIns="73152" tIns="36576" bIns="36576"/>
-          <a:lstStyle/>
-          <a:p>
-            <a:pPr algn="ctr">
-              <a:spcAft>
-                <a:spcPts val="0"/>
-              </a:spcAft>
-            </a:pPr>
-            <a:r>
-              <a:rPr sz="1500" b="1">
-                <a:solidFill>
-                  <a:srgbClr val="141B2D"/>
-                </a:solidFill>
-                <a:latin typeface="Verdana"/>
-              </a:rPr>
-              <a:t>Shopper speaks</a:t>
-            </a:r>
-          </a:p>
-          <a:p>
-            <a:pPr algn="ctr">
-              <a:spcAft>
-                <a:spcPts val="0"/>
-              </a:spcAft>
-            </a:pPr>
-            <a:r>
-              <a:rPr sz="1200" b="0">
-                <a:solidFill>
-                  <a:srgbClr val="5B667A"/>
-                </a:solidFill>
-                <a:latin typeface="Verdana"/>
-              </a:rPr>
-              <a:t>one hidden target,</a:t>
-            </a:r>
-          </a:p>
-          <a:p>
-            <a:pPr algn="ctr">
-              <a:spcAft>
-                <a:spcPts val="0"/>
-              </a:spcAft>
-            </a:pPr>
-            <a:r>
-              <a:rPr sz="1200" b="0">
-                <a:solidFill>
-                  <a:srgbClr val="5B667A"/>
-                </a:solidFill>
-                <a:latin typeface="Verdana"/>
-              </a:rPr>
-              <a:t>never named</a:t>
-            </a:r>
-          </a:p>
-        </p:txBody>
-      </p:sp>
-      <p:sp>
-        <p:nvSpPr>
-          <p:cNvPr id="6" name="Right Arrow 5"/>
-          <p:cNvSpPr/>
-          <p:nvPr/>
-        </p:nvSpPr>
-        <p:spPr>
-          <a:xfrm>
-            <a:off x="3749040" y="2267712"/>
-            <a:ext cx="457200" cy="201168"/>
-          </a:xfrm>
-          <a:prstGeom prst="rightArrow">
-            <a:avLst/>
-          </a:prstGeom>
-          <a:solidFill>
-            <a:srgbClr val="0F62FE"/>
-          </a:solidFill>
-          <a:ln>
-            <a:noFill/>
-          </a:ln>
-          <a:effectLst/>
-        </p:spPr>
-        <p:style>
-          <a:lnRef idx="1">
-            <a:schemeClr val="accent1"/>
-          </a:lnRef>
-          <a:fillRef idx="3">
-            <a:schemeClr val="accent1"/>
-          </a:fillRef>
-          <a:effectRef idx="2">
-            <a:schemeClr val="accent1"/>
-          </a:effectRef>
-          <a:fontRef idx="minor">
-            <a:schemeClr val="lt1"/>
-          </a:fontRef>
-        </p:style>
-        <p:txBody>
-          <a:bodyPr rtlCol="0" anchor="ctr"/>
-          <a:lstStyle/>
-          <a:p>
-            <a:pPr algn="ctr"/>
-          </a:p>
-        </p:txBody>
-      </p:sp>
-      <p:sp>
-        <p:nvSpPr>
-          <p:cNvPr id="7" name="Rounded Rectangle 6"/>
-          <p:cNvSpPr/>
-          <p:nvPr/>
-        </p:nvSpPr>
-        <p:spPr>
-          <a:xfrm>
-            <a:off x="4206240" y="1828800"/>
-            <a:ext cx="2834640" cy="1051560"/>
-          </a:xfrm>
-          <a:prstGeom prst="roundRect">
-            <a:avLst/>
-          </a:prstGeom>
-          <a:solidFill>
-            <a:srgbClr val="E4EDFD"/>
-          </a:solidFill>
-          <a:ln w="12700">
-            <a:solidFill>
-              <a:srgbClr val="D8DDE6"/>
-            </a:solidFill>
-          </a:ln>
-          <a:effectLst/>
-        </p:spPr>
-        <p:style>
-          <a:lnRef idx="1">
-            <a:schemeClr val="accent1"/>
-          </a:lnRef>
-          <a:fillRef idx="3">
-            <a:schemeClr val="accent1"/>
-          </a:fillRef>
-          <a:effectRef idx="2">
-            <a:schemeClr val="accent1"/>
-          </a:effectRef>
-          <a:fontRef idx="minor">
-            <a:schemeClr val="lt1"/>
-          </a:fontRef>
-        </p:style>
-        <p:txBody>
-          <a:bodyPr rtlCol="0" anchor="ctr" wrap="square" lIns="73152" rIns="73152" tIns="36576" bIns="36576"/>
-          <a:lstStyle/>
-          <a:p>
-            <a:pPr algn="ctr">
-              <a:spcAft>
-                <a:spcPts val="0"/>
-              </a:spcAft>
-            </a:pPr>
-            <a:r>
-              <a:rPr sz="1500" b="1">
-                <a:solidFill>
-                  <a:srgbClr val="141B2D"/>
-                </a:solidFill>
-                <a:latin typeface="Verdana"/>
-              </a:rPr>
-              <a:t>We answer</a:t>
-            </a:r>
-          </a:p>
-          <a:p>
-            <a:pPr algn="ctr">
-              <a:spcAft>
-                <a:spcPts val="0"/>
-              </a:spcAft>
-            </a:pPr>
-            <a:r>
-              <a:rPr sz="1200" b="0">
-                <a:solidFill>
-                  <a:srgbClr val="5B667A"/>
-                </a:solidFill>
-                <a:latin typeface="Verdana"/>
-              </a:rPr>
-              <a:t>return 10 products</a:t>
-            </a:r>
-          </a:p>
-          <a:p>
-            <a:pPr algn="ctr">
-              <a:spcAft>
-                <a:spcPts val="0"/>
-              </a:spcAft>
-            </a:pPr>
-            <a:r>
-              <a:rPr sz="1200" b="0">
-                <a:solidFill>
-                  <a:srgbClr val="5B667A"/>
-                </a:solidFill>
-                <a:latin typeface="Verdana"/>
-              </a:rPr>
-              <a:t>+ ask 1 question</a:t>
-            </a:r>
-          </a:p>
-        </p:txBody>
-      </p:sp>
-      <p:sp>
-        <p:nvSpPr>
-          <p:cNvPr id="8" name="Right Arrow 7"/>
-          <p:cNvSpPr/>
-          <p:nvPr/>
-        </p:nvSpPr>
-        <p:spPr>
-          <a:xfrm>
-            <a:off x="7132320" y="2267712"/>
-            <a:ext cx="457200" cy="201168"/>
-          </a:xfrm>
-          <a:prstGeom prst="rightArrow">
-            <a:avLst/>
-          </a:prstGeom>
-          <a:solidFill>
-            <a:srgbClr val="0F62FE"/>
-          </a:solidFill>
-          <a:ln>
-            <a:noFill/>
-          </a:ln>
-          <a:effectLst/>
-        </p:spPr>
-        <p:style>
-          <a:lnRef idx="1">
-            <a:schemeClr val="accent1"/>
-          </a:lnRef>
-          <a:fillRef idx="3">
-            <a:schemeClr val="accent1"/>
-          </a:fillRef>
-          <a:effectRef idx="2">
-            <a:schemeClr val="accent1"/>
-          </a:effectRef>
-          <a:fontRef idx="minor">
-            <a:schemeClr val="lt1"/>
-          </a:fontRef>
-        </p:style>
-        <p:txBody>
-          <a:bodyPr rtlCol="0" anchor="ctr"/>
-          <a:lstStyle/>
-          <a:p>
-            <a:pPr algn="ctr"/>
-          </a:p>
-        </p:txBody>
-      </p:sp>
-      <p:sp>
-        <p:nvSpPr>
-          <p:cNvPr id="9" name="Rounded Rectangle 8"/>
-          <p:cNvSpPr/>
-          <p:nvPr/>
-        </p:nvSpPr>
-        <p:spPr>
-          <a:xfrm>
-            <a:off x="7589520" y="1828800"/>
-            <a:ext cx="2834640" cy="1051560"/>
-          </a:xfrm>
-          <a:prstGeom prst="roundRect">
-            <a:avLst/>
-          </a:prstGeom>
-          <a:solidFill>
-            <a:srgbClr val="F4F6FA"/>
-          </a:solidFill>
-          <a:ln w="12700">
-            <a:solidFill>
-              <a:srgbClr val="D8DDE6"/>
-            </a:solidFill>
-          </a:ln>
-          <a:effectLst/>
-        </p:spPr>
-        <p:style>
-          <a:lnRef idx="1">
-            <a:schemeClr val="accent1"/>
-          </a:lnRef>
-          <a:fillRef idx="3">
-            <a:schemeClr val="accent1"/>
-          </a:fillRef>
-          <a:effectRef idx="2">
-            <a:schemeClr val="accent1"/>
-          </a:effectRef>
-          <a:fontRef idx="minor">
-            <a:schemeClr val="lt1"/>
-          </a:fontRef>
-        </p:style>
-        <p:txBody>
-          <a:bodyPr rtlCol="0" anchor="ctr" wrap="square" lIns="73152" rIns="73152" tIns="36576" bIns="36576"/>
-          <a:lstStyle/>
-          <a:p>
-            <a:pPr algn="ctr">
-              <a:spcAft>
-                <a:spcPts val="0"/>
-              </a:spcAft>
-            </a:pPr>
-            <a:r>
-              <a:rPr sz="1500" b="1">
-                <a:solidFill>
-                  <a:srgbClr val="141B2D"/>
-                </a:solidFill>
-                <a:latin typeface="Verdana"/>
-              </a:rPr>
-              <a:t>Grader checks</a:t>
-            </a:r>
-          </a:p>
-          <a:p>
-            <a:pPr algn="ctr">
-              <a:spcAft>
-                <a:spcPts val="0"/>
-              </a:spcAft>
-            </a:pPr>
-            <a:r>
-              <a:rPr sz="1200" b="0">
-                <a:solidFill>
-                  <a:srgbClr val="5B667A"/>
-                </a:solidFill>
-                <a:latin typeface="Verdana"/>
-              </a:rPr>
-              <a:t>is the target</a:t>
-            </a:r>
-          </a:p>
-          <a:p>
-            <a:pPr algn="ctr">
-              <a:spcAft>
-                <a:spcPts val="0"/>
-              </a:spcAft>
-            </a:pPr>
-            <a:r>
-              <a:rPr sz="1200" b="0">
-                <a:solidFill>
-                  <a:srgbClr val="5B667A"/>
-                </a:solidFill>
-                <a:latin typeface="Verdana"/>
-              </a:rPr>
-              <a:t>in those 10?</a:t>
-            </a:r>
-          </a:p>
-        </p:txBody>
-      </p:sp>
-      <p:sp>
-        <p:nvSpPr>
-          <p:cNvPr id="10" name="Rounded Rectangle 9"/>
-          <p:cNvSpPr/>
-          <p:nvPr/>
-        </p:nvSpPr>
-        <p:spPr>
-          <a:xfrm>
-            <a:off x="10972800" y="1828800"/>
-            <a:ext cx="685800" cy="1051560"/>
-          </a:xfrm>
-          <a:prstGeom prst="roundRect">
-            <a:avLst/>
-          </a:prstGeom>
-          <a:solidFill>
-            <a:srgbClr val="E6F3EC"/>
-          </a:solidFill>
-          <a:ln w="12700">
-            <a:solidFill>
-              <a:srgbClr val="0B7A4B"/>
-            </a:solidFill>
-          </a:ln>
-          <a:effectLst/>
-        </p:spPr>
-        <p:style>
-          <a:lnRef idx="1">
-            <a:schemeClr val="accent1"/>
-          </a:lnRef>
-          <a:fillRef idx="3">
-            <a:schemeClr val="accent1"/>
-          </a:fillRef>
-          <a:effectRef idx="2">
-            <a:schemeClr val="accent1"/>
-          </a:effectRef>
-          <a:fontRef idx="minor">
-            <a:schemeClr val="lt1"/>
-          </a:fontRef>
-        </p:style>
-        <p:txBody>
-          <a:bodyPr rtlCol="0" anchor="ctr" wrap="square" lIns="73152" rIns="73152" tIns="36576" bIns="36576"/>
-          <a:lstStyle/>
-          <a:p>
-            <a:pPr algn="ctr">
-              <a:spcAft>
-                <a:spcPts val="0"/>
-              </a:spcAft>
-            </a:pPr>
-            <a:r>
-              <a:rPr sz="1300" b="1">
-                <a:solidFill>
-                  <a:srgbClr val="0B7A4B"/>
-                </a:solidFill>
-                <a:latin typeface="Verdana"/>
-              </a:rPr>
-              <a:t>HIT</a:t>
-            </a:r>
-          </a:p>
-          <a:p>
-            <a:pPr algn="ctr">
-              <a:spcAft>
-                <a:spcPts val="0"/>
-              </a:spcAft>
-            </a:pPr>
-            <a:r>
-              <a:rPr sz="1000" b="0">
-                <a:solidFill>
-                  <a:srgbClr val="5B667A"/>
-                </a:solidFill>
-                <a:latin typeface="Verdana"/>
-              </a:rPr>
-              <a:t>session ends</a:t>
-            </a:r>
-          </a:p>
-        </p:txBody>
-      </p:sp>
-      <p:sp>
-        <p:nvSpPr>
-          <p:cNvPr id="11" name="Left Arrow 10"/>
-          <p:cNvSpPr/>
-          <p:nvPr/>
-        </p:nvSpPr>
-        <p:spPr>
-          <a:xfrm>
-            <a:off x="822960" y="3154680"/>
-            <a:ext cx="9509760" cy="310896"/>
-          </a:xfrm>
-          <a:prstGeom prst="leftArrow">
-            <a:avLst/>
-          </a:prstGeom>
-          <a:solidFill>
-            <a:srgbClr val="E4EDFD"/>
-          </a:solidFill>
-          <a:ln w="9525">
-            <a:solidFill>
-              <a:srgbClr val="0F62FE"/>
-            </a:solidFill>
-          </a:ln>
-          <a:effectLst/>
-        </p:spPr>
-        <p:style>
-          <a:lnRef idx="1">
-            <a:schemeClr val="accent1"/>
-          </a:lnRef>
-          <a:fillRef idx="3">
-            <a:schemeClr val="accent1"/>
-          </a:fillRef>
-          <a:effectRef idx="2">
-            <a:schemeClr val="accent1"/>
-          </a:effectRef>
-          <a:fontRef idx="minor">
-            <a:schemeClr val="lt1"/>
-          </a:fontRef>
-        </p:style>
-        <p:txBody>
-          <a:bodyPr rtlCol="0" anchor="ctr"/>
-          <a:lstStyle/>
-          <a:p>
-            <a:pPr algn="ctr"/>
-            <a:r>
-              <a:rPr sz="1100" b="1">
-                <a:solidFill>
-                  <a:srgbClr val="0F62FE"/>
-                </a:solidFill>
-                <a:latin typeface="Verdana"/>
-              </a:rPr>
-              <a:t>miss  →  next turn, up to 10 of them</a:t>
-            </a:r>
-          </a:p>
-        </p:txBody>
-      </p:sp>
-      <p:graphicFrame>
-        <p:nvGraphicFramePr>
-          <p:cNvPr id="12" name="Table 11"/>
-          <p:cNvGraphicFramePr>
-            <a:graphicFrameLocks noGrp="1"/>
-          </p:cNvGraphicFramePr>
-          <p:nvPr/>
-        </p:nvGraphicFramePr>
-        <p:xfrm>
-          <a:off x="640080" y="3977639"/>
-          <a:ext cx="10908791" cy="1371600"/>
-        </p:xfrm>
-        <a:graphic>
-          <a:graphicData uri="http://schemas.openxmlformats.org/drawingml/2006/table">
-            <a:tbl>
-              <a:tblPr firstRow="1">
-                <a:tableStyleId>{5C22544A-7EE6-4342-B048-85BDC9FD1C3A}</a:tableStyleId>
-              </a:tblPr>
-              <a:tblGrid>
-                <a:gridCol w="2016751"/>
-                <a:gridCol w="1100046"/>
-                <a:gridCol w="7791994"/>
-              </a:tblGrid>
-              <a:tr h="329184">
-                <a:tc>
-                  <a:txBody>
-                    <a:bodyPr/>
-                    <a:lstStyle/>
-                    <a:p>
-                      <a:r>
-                        <a:rPr sz="1100" b="1">
-                          <a:solidFill>
-                            <a:srgbClr val="FFFFFF"/>
-                          </a:solidFill>
-                          <a:latin typeface="Verdana"/>
-                        </a:rPr>
-                        <a:t>Term</a:t>
-                      </a:r>
-                    </a:p>
-                  </a:txBody>
-                  <a:tcPr marL="82296" marR="82296" marT="36576" marB="36576" anchor="ctr">
-                    <a:solidFill>
-                      <a:srgbClr val="141B2D"/>
-                    </a:solidFill>
-                  </a:tcPr>
-                </a:tc>
-                <a:tc>
-                  <a:txBody>
-                    <a:bodyPr/>
-                    <a:lstStyle/>
-                    <a:p>
-                      <a:r>
-                        <a:rPr sz="1100" b="1">
-                          <a:solidFill>
-                            <a:srgbClr val="FFFFFF"/>
-                          </a:solidFill>
-                          <a:latin typeface="Verdana"/>
-                        </a:rPr>
-                        <a:t>Weight</a:t>
-                      </a:r>
-                    </a:p>
-                  </a:txBody>
-                  <a:tcPr marL="82296" marR="82296" marT="36576" marB="36576" anchor="ctr">
-                    <a:solidFill>
-                      <a:srgbClr val="141B2D"/>
-                    </a:solidFill>
-                  </a:tcPr>
-                </a:tc>
-                <a:tc>
-                  <a:txBody>
-                    <a:bodyPr/>
-                    <a:lstStyle/>
-                    <a:p>
-                      <a:r>
-                        <a:rPr sz="1100" b="1">
-                          <a:solidFill>
-                            <a:srgbClr val="FFFFFF"/>
-                          </a:solidFill>
-                          <a:latin typeface="Verdana"/>
-                        </a:rPr>
-                        <a:t>What it rewards</a:t>
-                      </a:r>
-                    </a:p>
-                  </a:txBody>
-                  <a:tcPr marL="82296" marR="82296" marT="36576" marB="36576" anchor="ctr">
-                    <a:solidFill>
-                      <a:srgbClr val="141B2D"/>
-                    </a:solidFill>
-                  </a:tcPr>
-                </a:tc>
-              </a:tr>
-              <a:tr h="347472">
-                <a:tc>
-                  <a:txBody>
-                    <a:bodyPr wrap="square"/>
-                    <a:lstStyle/>
-                    <a:p>
-                      <a:r>
-                        <a:rPr sz="1200" b="0">
-                          <a:solidFill>
-                            <a:srgbClr val="141B2D"/>
-                          </a:solidFill>
-                          <a:latin typeface="Verdana"/>
-                        </a:rPr>
-                        <a:t>HitRate@10</a:t>
-                      </a:r>
-                    </a:p>
-                  </a:txBody>
-                  <a:tcPr marL="82296" marR="82296" marT="36576" marB="36576" anchor="ctr">
-                    <a:solidFill>
-                      <a:srgbClr val="FFFFFF"/>
-                    </a:solidFill>
-                  </a:tcPr>
-                </a:tc>
-                <a:tc>
-                  <a:txBody>
-                    <a:bodyPr wrap="square"/>
-                    <a:lstStyle/>
-                    <a:p>
-                      <a:r>
-                        <a:rPr sz="1200" b="0">
-                          <a:solidFill>
-                            <a:srgbClr val="141B2D"/>
-                          </a:solidFill>
-                          <a:latin typeface="Verdana"/>
-                        </a:rPr>
-                        <a:t>0.50</a:t>
-                      </a:r>
-                    </a:p>
-                  </a:txBody>
-                  <a:tcPr marL="82296" marR="82296" marT="36576" marB="36576" anchor="ctr">
-                    <a:solidFill>
-                      <a:srgbClr val="FFFFFF"/>
-                    </a:solidFill>
-                  </a:tcPr>
-                </a:tc>
-                <a:tc>
-                  <a:txBody>
-                    <a:bodyPr wrap="square"/>
-                    <a:lstStyle/>
-                    <a:p>
-                      <a:r>
-                        <a:rPr sz="1200" b="0">
-                          <a:solidFill>
-                            <a:srgbClr val="141B2D"/>
-                          </a:solidFill>
-                          <a:latin typeface="Verdana"/>
-                        </a:rPr>
-                        <a:t>Finding the target at all, in any of the 10 slots.</a:t>
-                      </a:r>
-                    </a:p>
-                  </a:txBody>
-                  <a:tcPr marL="82296" marR="82296" marT="36576" marB="36576" anchor="ctr">
-                    <a:solidFill>
-                      <a:srgbClr val="FFFFFF"/>
-                    </a:solidFill>
-                  </a:tcPr>
-                </a:tc>
-              </a:tr>
-              <a:tr h="347472">
-                <a:tc>
-                  <a:txBody>
-                    <a:bodyPr wrap="square"/>
-                    <a:lstStyle/>
-                    <a:p>
-                      <a:r>
-                        <a:rPr sz="1200" b="0">
-                          <a:solidFill>
-                            <a:srgbClr val="141B2D"/>
-                          </a:solidFill>
-                          <a:latin typeface="Verdana"/>
-                        </a:rPr>
-                        <a:t>MRR</a:t>
-                      </a:r>
-                    </a:p>
-                  </a:txBody>
-                  <a:tcPr marL="82296" marR="82296" marT="36576" marB="36576" anchor="ctr">
-                    <a:solidFill>
-                      <a:srgbClr val="F4F6FA"/>
-                    </a:solidFill>
-                  </a:tcPr>
-                </a:tc>
-                <a:tc>
-                  <a:txBody>
-                    <a:bodyPr wrap="square"/>
-                    <a:lstStyle/>
-                    <a:p>
-                      <a:r>
-                        <a:rPr sz="1200" b="0">
-                          <a:solidFill>
-                            <a:srgbClr val="141B2D"/>
-                          </a:solidFill>
-                          <a:latin typeface="Verdana"/>
-                        </a:rPr>
-                        <a:t>0.30</a:t>
-                      </a:r>
-                    </a:p>
-                  </a:txBody>
-                  <a:tcPr marL="82296" marR="82296" marT="36576" marB="36576" anchor="ctr">
-                    <a:solidFill>
-                      <a:srgbClr val="F4F6FA"/>
-                    </a:solidFill>
-                  </a:tcPr>
-                </a:tc>
-                <a:tc>
-                  <a:txBody>
-                    <a:bodyPr wrap="square"/>
-                    <a:lstStyle/>
-                    <a:p>
-                      <a:r>
-                        <a:rPr sz="1200" b="1">
-                          <a:solidFill>
-                            <a:srgbClr val="0F62FE"/>
-                          </a:solidFill>
-                          <a:latin typeface="Verdana"/>
-                        </a:rPr>
-                        <a:t>Its rank at the FIRST hit — not the best rank we ever reached.</a:t>
-                      </a:r>
-                    </a:p>
-                  </a:txBody>
-                  <a:tcPr marL="82296" marR="82296" marT="36576" marB="36576" anchor="ctr">
-                    <a:solidFill>
-                      <a:srgbClr val="F4F6FA"/>
-                    </a:solidFill>
-                  </a:tcPr>
-                </a:tc>
-              </a:tr>
-              <a:tr h="347472">
-                <a:tc>
-                  <a:txBody>
-                    <a:bodyPr wrap="square"/>
-                    <a:lstStyle/>
-                    <a:p>
-                      <a:r>
-                        <a:rPr sz="1200" b="0">
-                          <a:solidFill>
-                            <a:srgbClr val="141B2D"/>
-                          </a:solidFill>
-                          <a:latin typeface="Verdana"/>
-                        </a:rPr>
-                        <a:t>Efficiency</a:t>
-                      </a:r>
-                    </a:p>
-                  </a:txBody>
-                  <a:tcPr marL="82296" marR="82296" marT="36576" marB="36576" anchor="ctr">
-                    <a:solidFill>
-                      <a:srgbClr val="FFFFFF"/>
-                    </a:solidFill>
-                  </a:tcPr>
-                </a:tc>
-                <a:tc>
-                  <a:txBody>
-                    <a:bodyPr wrap="square"/>
-                    <a:lstStyle/>
-                    <a:p>
-                      <a:r>
-                        <a:rPr sz="1200" b="0">
-                          <a:solidFill>
-                            <a:srgbClr val="141B2D"/>
-                          </a:solidFill>
-                          <a:latin typeface="Verdana"/>
-                        </a:rPr>
-                        <a:t>0.20</a:t>
-                      </a:r>
-                    </a:p>
-                  </a:txBody>
-                  <a:tcPr marL="82296" marR="82296" marT="36576" marB="36576" anchor="ctr">
-                    <a:solidFill>
-                      <a:srgbClr val="FFFFFF"/>
-                    </a:solidFill>
-                  </a:tcPr>
-                </a:tc>
-                <a:tc>
-                  <a:txBody>
-                    <a:bodyPr wrap="square"/>
-                    <a:lstStyle/>
-                    <a:p>
-                      <a:r>
-                        <a:rPr sz="1200" b="0">
-                          <a:solidFill>
-                            <a:srgbClr val="141B2D"/>
-                          </a:solidFill>
-                          <a:latin typeface="Verdana"/>
-                        </a:rPr>
-                        <a:t>Finding it in fewer turns. (11 − turns) / 10.</a:t>
-                      </a:r>
-                    </a:p>
-                  </a:txBody>
-                  <a:tcPr marL="82296" marR="82296" marT="36576" marB="36576" anchor="ctr">
-                    <a:solidFill>
-                      <a:srgbClr val="FFFFFF"/>
-                    </a:solidFill>
-                  </a:tcPr>
-                </a:tc>
-              </a:tr>
-            </a:tbl>
-          </a:graphicData>
-        </a:graphic>
-      </p:graphicFrame>
-      <p:sp>
-        <p:nvSpPr>
-          <p:cNvPr id="13" name="TextBox 12"/>
-          <p:cNvSpPr txBox="1"/>
-          <p:nvPr/>
-        </p:nvSpPr>
-        <p:spPr>
-          <a:xfrm>
-            <a:off x="640080" y="5623560"/>
-            <a:ext cx="10881360" cy="457200"/>
-          </a:xfrm>
-          <a:prstGeom prst="rect">
-            <a:avLst/>
-          </a:prstGeom>
-          <a:noFill/>
-        </p:spPr>
-        <p:txBody>
-          <a:bodyPr wrap="square" lIns="0" rIns="0" tIns="0" bIns="0">
-            <a:spAutoFit/>
-          </a:bodyPr>
-          <a:lstStyle/>
-          <a:p>
-            <a:r>
-              <a:rPr sz="1300" b="1">
-                <a:solidFill>
-                  <a:srgbClr val="0F62FE"/>
-                </a:solidFill>
-                <a:latin typeface="Verdana"/>
-              </a:rPr>
-              <a:t>Consequence we designed around: an earlier hit at a worse rank still pays. Speed beats polish.</a:t>
-            </a:r>
-          </a:p>
-        </p:txBody>
-      </p:sp>
-    </p:spTree>
-  </p:cSld>
-  <p:clrMapOvr>
-    <a:masterClrMapping/>
-  </p:clrMapOvr>
-</p:sld>
-</file>
-
-<file path=ppt/slides/slide20.xml><?xml version="1.0" encoding="utf-8"?>
-<p:sld xmlns:a="http://schemas.openxmlformats.org/drawingml/2006/main" xmlns:p="http://schemas.openxmlformats.org/presentationml/2006/main" xmlns:r="http://schemas.openxmlformats.org/officeDocument/2006/relationships">
-  <p:cSld>
-    <p:spTree>
-      <p:nvGrpSpPr>
-        <p:cNvPr id="1" name=""/>
-        <p:cNvGrpSpPr/>
-        <p:nvPr/>
-      </p:nvGrpSpPr>
-      <p:grpSpPr/>
-      <p:sp>
-        <p:nvSpPr>
-          <p:cNvPr id="2" name="TextBox 1"/>
-          <p:cNvSpPr txBox="1"/>
-          <p:nvPr/>
-        </p:nvSpPr>
-        <p:spPr>
-          <a:xfrm>
-            <a:off x="640080" y="384048"/>
-            <a:ext cx="10881360" cy="274320"/>
-          </a:xfrm>
-          <a:prstGeom prst="rect">
-            <a:avLst/>
-          </a:prstGeom>
-          <a:noFill/>
-        </p:spPr>
-        <p:txBody>
-          <a:bodyPr wrap="square" lIns="0" rIns="0" tIns="0" bIns="0">
-            <a:spAutoFit/>
-          </a:bodyPr>
-          <a:lstStyle/>
-          <a:p>
-            <a:pPr>
-              <a:spcAft>
-                <a:spcPts val="0"/>
-              </a:spcAft>
-            </a:pPr>
-            <a:r>
-              <a:rPr sz="1100" b="1">
-                <a:solidFill>
-                  <a:srgbClr val="0F62FE"/>
-                </a:solidFill>
-                <a:latin typeface="Verdana"/>
-              </a:rPr>
               <a:t>ENGINEERING</a:t>
             </a:r>
           </a:p>
@@ -14759,7 +17098,7 @@
 </p:sld>
 </file>
 
-<file path=ppt/slides/slide21.xml><?xml version="1.0" encoding="utf-8"?>
+<file path=ppt/slides/slide24.xml><?xml version="1.0" encoding="utf-8"?>
 <p:sld xmlns:a="http://schemas.openxmlformats.org/drawingml/2006/main" xmlns:p="http://schemas.openxmlformats.org/presentationml/2006/main" xmlns:r="http://schemas.openxmlformats.org/officeDocument/2006/relationships">
   <p:cSld>
     <p:spTree>
@@ -15477,7 +17816,7 @@
 </p:sld>
 </file>
 
-<file path=ppt/slides/slide22.xml><?xml version="1.0" encoding="utf-8"?>
+<file path=ppt/slides/slide25.xml><?xml version="1.0" encoding="utf-8"?>
 <p:sld xmlns:a="http://schemas.openxmlformats.org/drawingml/2006/main" xmlns:p="http://schemas.openxmlformats.org/presentationml/2006/main" xmlns:r="http://schemas.openxmlformats.org/officeDocument/2006/relationships">
   <p:cSld>
     <p:spTree>
@@ -24356,7 +26695,7 @@
                 </a:solidFill>
                 <a:latin typeface="Verdana"/>
               </a:rPr>
-              <a:t>PROVENANCE</a:t>
+              <a:t>PROVENANCE, 1 OF 2</a:t>
             </a:r>
           </a:p>
         </p:txBody>
@@ -24390,7 +26729,7 @@
                 </a:solidFill>
                 <a:latin typeface="Georgia"/>
               </a:rPr>
-              <a:t>What is standard, what is adapted, what is ours</a:t>
+              <a:t>What is standard, what is adapted</a:t>
             </a:r>
           </a:p>
         </p:txBody>
@@ -24449,7 +26788,7 @@
         </p:nvGraphicFramePr>
         <p:xfrm>
           <a:off x="640080" y="1536192"/>
-          <a:ext cx="10908789" cy="4535424"/>
+          <a:ext cx="10908789" cy="3986784"/>
         </p:xfrm>
         <a:graphic>
           <a:graphicData uri="http://schemas.openxmlformats.org/drawingml/2006/table">
@@ -24553,7 +26892,7 @@
                   </a:tcPr>
                 </a:tc>
               </a:tr>
-              <a:tr h="420624">
+              <a:tr h="457200">
                 <a:tc>
                   <a:txBody>
                     <a:bodyPr wrap="square"/>
@@ -24643,7 +26982,7 @@
                   </a:tcPr>
                 </a:tc>
               </a:tr>
-              <a:tr h="420624">
+              <a:tr h="457200">
                 <a:tc>
                   <a:txBody>
                     <a:bodyPr wrap="square"/>
@@ -24733,7 +27072,7 @@
                   </a:tcPr>
                 </a:tc>
               </a:tr>
-              <a:tr h="420624">
+              <a:tr h="457200">
                 <a:tc>
                   <a:txBody>
                     <a:bodyPr wrap="square"/>
@@ -24823,7 +27162,7 @@
                   </a:tcPr>
                 </a:tc>
               </a:tr>
-              <a:tr h="420624">
+              <a:tr h="457200">
                 <a:tc>
                   <a:txBody>
                     <a:bodyPr wrap="square"/>
@@ -24913,7 +27252,7 @@
                   </a:tcPr>
                 </a:tc>
               </a:tr>
-              <a:tr h="420624">
+              <a:tr h="457200">
                 <a:tc>
                   <a:txBody>
                     <a:bodyPr wrap="square"/>
@@ -25003,7 +27342,7 @@
                   </a:tcPr>
                 </a:tc>
               </a:tr>
-              <a:tr h="420624">
+              <a:tr h="457200">
                 <a:tc>
                   <a:txBody>
                     <a:bodyPr wrap="square"/>
@@ -25093,7 +27432,7 @@
                   </a:tcPr>
                 </a:tc>
               </a:tr>
-              <a:tr h="420624">
+              <a:tr h="457200">
                 <a:tc>
                   <a:txBody>
                     <a:bodyPr wrap="square"/>
@@ -25183,7 +27522,7 @@
                   </a:tcPr>
                 </a:tc>
               </a:tr>
-              <a:tr h="420624">
+              <a:tr h="457200">
                 <a:tc>
                   <a:txBody>
                     <a:bodyPr wrap="square"/>
@@ -25196,7 +27535,7 @@
                           </a:solidFill>
                           <a:latin typeface="Verdana"/>
                         </a:rPr>
-                        <a:t>Popularity prior</a:t>
+                        <a:t>LM eager prediction</a:t>
                       </a:r>
                     </a:p>
                   </a:txBody>
@@ -25218,7 +27557,7 @@
                           </a:solidFill>
                           <a:latin typeface="Verdana"/>
                         </a:rPr>
-                        <a:t>Popularity bias is a known recsys hazard — Abdollahpouri et al., RecSys 2017</a:t>
+                        <a:t>Salazar et al., pseudo-log-likelihood scoring, ACL 2020 · entropy gating is active-learning folklore</a:t>
                       </a:r>
                     </a:p>
                   </a:txBody>
@@ -25240,7 +27579,7 @@
                           </a:solidFill>
                           <a:latin typeface="Verdana"/>
                         </a:rPr>
-                        <a:t>Ours: entered as one RRF vote over the pool the other legs found, never as a score over the catalog, and doubled only when the shopper asks us to choose.</a:t>
+                        <a:t>distilbert scores every undisclosed attribute's closed vocabulary against the shopper's own turn; fills a gap only below a calibrated entropy gate. Measured net-neutral, so it ships optional, off by default — see next slide.</a:t>
                       </a:r>
                     </a:p>
                   </a:txBody>
@@ -25258,191 +27597,11 @@
                       <a:r>
                         <a:rPr sz="950" b="1">
                           <a:solidFill>
-                            <a:srgbClr val="0B7A4B"/>
-                          </a:solidFill>
-                          <a:latin typeface="Verdana"/>
-                        </a:rPr>
-                        <a:t>OURS</a:t>
-                      </a:r>
-                    </a:p>
-                  </a:txBody>
-                  <a:tcPr marL="82296" marR="82296" marT="36576" marB="36576" anchor="ctr">
-                    <a:solidFill>
-                      <a:srgbClr val="F4F6FA"/>
-                    </a:solidFill>
-                  </a:tcPr>
-                </a:tc>
-              </a:tr>
-              <a:tr h="420624">
-                <a:tc>
-                  <a:txBody>
-                    <a:bodyPr wrap="square"/>
-                    <a:lstStyle/>
-                    <a:p>
-                      <a:r>
-                        <a:rPr sz="950" b="0">
-                          <a:solidFill>
-                            <a:srgbClr val="141B2D"/>
-                          </a:solidFill>
-                          <a:latin typeface="Verdana"/>
-                        </a:rPr>
-                        <a:t>Dropping shown items</a:t>
-                      </a:r>
-                    </a:p>
-                  </a:txBody>
-                  <a:tcPr marL="82296" marR="82296" marT="36576" marB="36576" anchor="ctr">
-                    <a:solidFill>
-                      <a:srgbClr val="FFFFFF"/>
-                    </a:solidFill>
-                  </a:tcPr>
-                </a:tc>
-                <a:tc>
-                  <a:txBody>
-                    <a:bodyPr wrap="square"/>
-                    <a:lstStyle/>
-                    <a:p>
-                      <a:r>
-                        <a:rPr sz="950" b="0">
-                          <a:solidFill>
-                            <a:srgbClr val="141B2D"/>
-                          </a:solidFill>
-                          <a:latin typeface="Verdana"/>
-                        </a:rPr>
-                        <a:t>No paper. It falls out of reading the scorer.</a:t>
-                      </a:r>
-                    </a:p>
-                  </a:txBody>
-                  <a:tcPr marL="82296" marR="82296" marT="36576" marB="36576" anchor="ctr">
-                    <a:solidFill>
-                      <a:srgbClr val="FFFFFF"/>
-                    </a:solidFill>
-                  </a:tcPr>
-                </a:tc>
-                <a:tc>
-                  <a:txBody>
-                    <a:bodyPr wrap="square"/>
-                    <a:lstStyle/>
-                    <a:p>
-                      <a:r>
-                        <a:rPr sz="950" b="0">
-                          <a:solidFill>
-                            <a:srgbClr val="141B2D"/>
-                          </a:solidFill>
-                          <a:latin typeface="Verdana"/>
-                        </a:rPr>
-                        <a:t>The session ends at first hit, so a further turn proves every item shown is wrong. Our largest single win, +0.084.</a:t>
-                      </a:r>
-                    </a:p>
-                  </a:txBody>
-                  <a:tcPr marL="82296" marR="82296" marT="36576" marB="36576" anchor="ctr">
-                    <a:solidFill>
-                      <a:srgbClr val="FFFFFF"/>
-                    </a:solidFill>
-                  </a:tcPr>
-                </a:tc>
-                <a:tc>
-                  <a:txBody>
-                    <a:bodyPr wrap="square"/>
-                    <a:lstStyle/>
-                    <a:p>
-                      <a:r>
-                        <a:rPr sz="950" b="1">
-                          <a:solidFill>
-                            <a:srgbClr val="0B7A4B"/>
-                          </a:solidFill>
-                          <a:latin typeface="Verdana"/>
-                        </a:rPr>
-                        <a:t>OURS</a:t>
-                      </a:r>
-                    </a:p>
-                  </a:txBody>
-                  <a:tcPr marL="82296" marR="82296" marT="36576" marB="36576" anchor="ctr">
-                    <a:solidFill>
-                      <a:srgbClr val="FFFFFF"/>
-                    </a:solidFill>
-                  </a:tcPr>
-                </a:tc>
-              </a:tr>
-              <a:tr h="420624">
-                <a:tc>
-                  <a:txBody>
-                    <a:bodyPr wrap="square"/>
-                    <a:lstStyle/>
-                    <a:p>
-                      <a:r>
-                        <a:rPr sz="950" b="0">
-                          <a:solidFill>
-                            <a:srgbClr val="141B2D"/>
-                          </a:solidFill>
-                          <a:latin typeface="Verdana"/>
-                        </a:rPr>
-                        <a:t>Boost, never filter</a:t>
-                      </a:r>
-                    </a:p>
-                  </a:txBody>
-                  <a:tcPr marL="82296" marR="82296" marT="36576" marB="36576" anchor="ctr">
-                    <a:solidFill>
-                      <a:srgbClr val="F4F6FA"/>
-                    </a:solidFill>
-                  </a:tcPr>
-                </a:tc>
-                <a:tc>
-                  <a:txBody>
-                    <a:bodyPr wrap="square"/>
-                    <a:lstStyle/>
-                    <a:p>
-                      <a:r>
-                        <a:rPr sz="950" b="0">
-                          <a:solidFill>
-                            <a:srgbClr val="141B2D"/>
-                          </a:solidFill>
-                          <a:latin typeface="Verdana"/>
-                        </a:rPr>
-                        <a:t>Soft constraints are folklore; the failure mode here was measured.</a:t>
-                      </a:r>
-                    </a:p>
-                  </a:txBody>
-                  <a:tcPr marL="82296" marR="82296" marT="36576" marB="36576" anchor="ctr">
-                    <a:solidFill>
-                      <a:srgbClr val="F4F6FA"/>
-                    </a:solidFill>
-                  </a:tcPr>
-                </a:tc>
-                <a:tc>
-                  <a:txBody>
-                    <a:bodyPr wrap="square"/>
-                    <a:lstStyle/>
-                    <a:p>
-                      <a:r>
-                        <a:rPr sz="950" b="0">
-                          <a:solidFill>
-                            <a:srgbClr val="141B2D"/>
-                          </a:solidFill>
-                          <a:latin typeface="Verdana"/>
-                        </a:rPr>
-                        <a:t>Our own attribute labels disagree with the target 16–37% of the time, so a hard filter deletes the answer. Agreement scores ±1 and deletes nothing.</a:t>
-                      </a:r>
-                    </a:p>
-                  </a:txBody>
-                  <a:tcPr marL="82296" marR="82296" marT="36576" marB="36576" anchor="ctr">
-                    <a:solidFill>
-                      <a:srgbClr val="F4F6FA"/>
-                    </a:solidFill>
-                  </a:tcPr>
-                </a:tc>
-                <a:tc>
-                  <a:txBody>
-                    <a:bodyPr wrap="square"/>
-                    <a:lstStyle/>
-                    <a:p>
-                      <a:r>
-                        <a:rPr sz="950" b="1">
-                          <a:solidFill>
-                            <a:srgbClr val="0B7A4B"/>
-                          </a:solidFill>
-                          <a:latin typeface="Verdana"/>
-                        </a:rPr>
-                        <a:t>OURS</a:t>
+                            <a:srgbClr val="0F62FE"/>
+                          </a:solidFill>
+                          <a:latin typeface="Verdana"/>
+                        </a:rPr>
+                        <a:t>ADAPTED</a:t>
                       </a:r>
                     </a:p>
                   </a:txBody>
@@ -25465,7 +27624,7 @@
         </p:nvSpPr>
         <p:spPr>
           <a:xfrm>
-            <a:off x="640080" y="6309360"/>
+            <a:off x="640080" y="5669280"/>
             <a:ext cx="10881360" cy="457200"/>
           </a:xfrm>
           <a:prstGeom prst="rect">
@@ -25486,7 +27645,7 @@
                 </a:solidFill>
                 <a:latin typeface="Verdana"/>
               </a:rPr>
-              <a:t>Every retrieval primitive here is off the shelf and unmodified. The score came from how they are combined, and from three mechanisms this task needed that the literature does not supply.</a:t>
+              <a:t>Every row here is a published mechanism; the adaptations are the gating and combination logic layered on top, each one measured before being kept.</a:t>
             </a:r>
           </a:p>
         </p:txBody>

</xml_diff>

<commit_message>
docs: trim agent.py comments, refresh deck with post-fix metrics
starter/agent.py: shortened/removed comments per review -- multi-line
explanations collapsed to one or two lines, redundant restate-the-code
comments dropped, stale #N ticket references removed. No logic changes
(verified: syntax check, smoke eval, and targeted re-probe of two known
samples landed on the same hit/miss as before).

scripts/build_deck.py + dist/techjam_track4.pptx: updated the title
slide's headline metrics and added the two fixes from the last commit
(phrase span cap, non-answer prototype coverage) to the "every idea we
measured" ledger, with their measured full-set deltas.

Co-Authored-By: Claude Sonnet 5 <noreply@anthropic.com>
Claude-Session: https://claude.ai/code/session_01S9bEFSCWQKHjB4BSKG1xbw
</commit_message>
<xml_diff>
--- a/dist/techjam_track4.pptx
+++ b/dist/techjam_track4.pptx
@@ -3326,7 +3326,7 @@
                 </a:solidFill>
                 <a:latin typeface="Verdana"/>
               </a:rPr>
-              <a:t>0.794</a:t>
+              <a:t>0.822</a:t>
             </a:r>
           </a:p>
           <a:p>
@@ -3401,7 +3401,7 @@
                 </a:solidFill>
                 <a:latin typeface="Verdana"/>
               </a:rPr>
-              <a:t>0.945</a:t>
+              <a:t>0.965</a:t>
             </a:r>
           </a:p>
           <a:p>
@@ -3476,7 +3476,7 @@
                 </a:solidFill>
                 <a:latin typeface="Verdana"/>
               </a:rPr>
-              <a:t>0.553</a:t>
+              <a:t>0.598</a:t>
             </a:r>
           </a:p>
           <a:p>
@@ -3551,7 +3551,7 @@
                 </a:solidFill>
                 <a:latin typeface="Verdana"/>
               </a:rPr>
-              <a:t>3.25</a:t>
+              <a:t>2.99</a:t>
             </a:r>
           </a:p>
           <a:p>
@@ -5203,7 +5203,7 @@
         </p:nvGraphicFramePr>
         <p:xfrm>
           <a:off x="640080" y="1417320"/>
-          <a:ext cx="10908790" cy="4242816"/>
+          <a:ext cx="10908790" cy="4736592"/>
         </p:xfrm>
         <a:graphic>
           <a:graphicData uri="http://schemas.openxmlformats.org/drawingml/2006/table">
@@ -5500,7 +5500,7 @@
                           </a:solidFill>
                           <a:latin typeface="Verdana"/>
                         </a:rPr>
-                        <a:t>Boost instead of filter</a:t>
+                        <a:t>Cover catalog jargon in non-answer prototypes</a:t>
                       </a:r>
                     </a:p>
                   </a:txBody>
@@ -5522,7 +5522,7 @@
                           </a:solidFill>
                           <a:latin typeface="Verdana"/>
                         </a:rPr>
-                        <a:t>Our own labels disagree with the target 16–37% of the time.</a:t>
+                        <a:t>"Imported." is a real disclosure, not a decline, just because it isn't a full sentence.</a:t>
                       </a:r>
                     </a:p>
                   </a:txBody>
@@ -5544,7 +5544,7 @@
                           </a:solidFill>
                           <a:latin typeface="Verdana"/>
                         </a:rPr>
-                        <a:t>+0.013</a:t>
+                        <a:t>+0.022</a:t>
                       </a:r>
                     </a:p>
                   </a:txBody>
@@ -5590,7 +5590,7 @@
                           </a:solidFill>
                           <a:latin typeface="Verdana"/>
                         </a:rPr>
-                        <a:t>Ask answerable questions first</a:t>
+                        <a:t>Boost instead of filter</a:t>
                       </a:r>
                     </a:p>
                   </a:txBody>
@@ -5612,7 +5612,7 @@
                           </a:solidFill>
                           <a:latin typeface="Verdana"/>
                         </a:rPr>
-                        <a:t>A question that gets no answer burns a whole turn.</a:t>
+                        <a:t>Our own labels disagree with the target 16–37% of the time.</a:t>
                       </a:r>
                     </a:p>
                   </a:txBody>
@@ -5634,7 +5634,7 @@
                           </a:solidFill>
                           <a:latin typeface="Verdana"/>
                         </a:rPr>
-                        <a:t>+0.011</a:t>
+                        <a:t>+0.013</a:t>
                       </a:r>
                     </a:p>
                   </a:txBody>
@@ -5680,12 +5680,192 @@
                           </a:solidFill>
                           <a:latin typeface="Verdana"/>
                         </a:rPr>
+                        <a:t>Ask answerable questions first</a:t>
+                      </a:r>
+                    </a:p>
+                  </a:txBody>
+                  <a:tcPr marL="82296" marR="82296" marT="36576" marB="36576" anchor="ctr">
+                    <a:solidFill>
+                      <a:srgbClr val="FFFFFF"/>
+                    </a:solidFill>
+                  </a:tcPr>
+                </a:tc>
+                <a:tc>
+                  <a:txBody>
+                    <a:bodyPr wrap="square"/>
+                    <a:lstStyle/>
+                    <a:p>
+                      <a:r>
+                        <a:rPr sz="850" b="0">
+                          <a:solidFill>
+                            <a:srgbClr val="141B2D"/>
+                          </a:solidFill>
+                          <a:latin typeface="Verdana"/>
+                        </a:rPr>
+                        <a:t>A question that gets no answer burns a whole turn.</a:t>
+                      </a:r>
+                    </a:p>
+                  </a:txBody>
+                  <a:tcPr marL="82296" marR="82296" marT="36576" marB="36576" anchor="ctr">
+                    <a:solidFill>
+                      <a:srgbClr val="FFFFFF"/>
+                    </a:solidFill>
+                  </a:tcPr>
+                </a:tc>
+                <a:tc>
+                  <a:txBody>
+                    <a:bodyPr wrap="square"/>
+                    <a:lstStyle/>
+                    <a:p>
+                      <a:r>
+                        <a:rPr sz="850" b="1">
+                          <a:solidFill>
+                            <a:srgbClr val="0B7A4B"/>
+                          </a:solidFill>
+                          <a:latin typeface="Verdana"/>
+                        </a:rPr>
+                        <a:t>+0.011</a:t>
+                      </a:r>
+                    </a:p>
+                  </a:txBody>
+                  <a:tcPr marL="82296" marR="82296" marT="36576" marB="36576" anchor="ctr">
+                    <a:solidFill>
+                      <a:srgbClr val="FFFFFF"/>
+                    </a:solidFill>
+                  </a:tcPr>
+                </a:tc>
+                <a:tc>
+                  <a:txBody>
+                    <a:bodyPr wrap="square"/>
+                    <a:lstStyle/>
+                    <a:p>
+                      <a:r>
+                        <a:rPr sz="850" b="1">
+                          <a:solidFill>
+                            <a:srgbClr val="0B7A4B"/>
+                          </a:solidFill>
+                          <a:latin typeface="Verdana"/>
+                        </a:rPr>
+                        <a:t>SHIPPED</a:t>
+                      </a:r>
+                    </a:p>
+                  </a:txBody>
+                  <a:tcPr marL="82296" marR="82296" marT="36576" marB="36576" anchor="ctr">
+                    <a:solidFill>
+                      <a:srgbClr val="FFFFFF"/>
+                    </a:solidFill>
+                  </a:tcPr>
+                </a:tc>
+              </a:tr>
+              <a:tr h="246888">
+                <a:tc>
+                  <a:txBody>
+                    <a:bodyPr wrap="square"/>
+                    <a:lstStyle/>
+                    <a:p>
+                      <a:r>
+                        <a:rPr sz="850" b="0">
+                          <a:solidFill>
+                            <a:srgbClr val="141B2D"/>
+                          </a:solidFill>
+                          <a:latin typeface="Verdana"/>
+                        </a:rPr>
                         <a:t>Popularity prior leg</a:t>
                       </a:r>
                     </a:p>
                   </a:txBody>
                   <a:tcPr marL="82296" marR="82296" marT="36576" marB="36576" anchor="ctr">
                     <a:solidFill>
+                      <a:srgbClr val="F4F6FA"/>
+                    </a:solidFill>
+                  </a:tcPr>
+                </a:tc>
+                <a:tc>
+                  <a:txBody>
+                    <a:bodyPr wrap="square"/>
+                    <a:lstStyle/>
+                    <a:p>
+                      <a:r>
+                        <a:rPr sz="850" b="0">
+                          <a:solidFill>
+                            <a:srgbClr val="141B2D"/>
+                          </a:solidFill>
+                          <a:latin typeface="Verdana"/>
+                        </a:rPr>
+                        <a:t>63% of the hidden targets sit in the catalog's top 1% by review count.</a:t>
+                      </a:r>
+                    </a:p>
+                  </a:txBody>
+                  <a:tcPr marL="82296" marR="82296" marT="36576" marB="36576" anchor="ctr">
+                    <a:solidFill>
+                      <a:srgbClr val="F4F6FA"/>
+                    </a:solidFill>
+                  </a:tcPr>
+                </a:tc>
+                <a:tc>
+                  <a:txBody>
+                    <a:bodyPr wrap="square"/>
+                    <a:lstStyle/>
+                    <a:p>
+                      <a:r>
+                        <a:rPr sz="850" b="1">
+                          <a:solidFill>
+                            <a:srgbClr val="0B7A4B"/>
+                          </a:solidFill>
+                          <a:latin typeface="Verdana"/>
+                        </a:rPr>
+                        <a:t>+0.006</a:t>
+                      </a:r>
+                    </a:p>
+                  </a:txBody>
+                  <a:tcPr marL="82296" marR="82296" marT="36576" marB="36576" anchor="ctr">
+                    <a:solidFill>
+                      <a:srgbClr val="F4F6FA"/>
+                    </a:solidFill>
+                  </a:tcPr>
+                </a:tc>
+                <a:tc>
+                  <a:txBody>
+                    <a:bodyPr wrap="square"/>
+                    <a:lstStyle/>
+                    <a:p>
+                      <a:r>
+                        <a:rPr sz="850" b="1">
+                          <a:solidFill>
+                            <a:srgbClr val="0B7A4B"/>
+                          </a:solidFill>
+                          <a:latin typeface="Verdana"/>
+                        </a:rPr>
+                        <a:t>SHIPPED</a:t>
+                      </a:r>
+                    </a:p>
+                  </a:txBody>
+                  <a:tcPr marL="82296" marR="82296" marT="36576" marB="36576" anchor="ctr">
+                    <a:solidFill>
+                      <a:srgbClr val="F4F6FA"/>
+                    </a:solidFill>
+                  </a:tcPr>
+                </a:tc>
+              </a:tr>
+              <a:tr h="246888">
+                <a:tc>
+                  <a:txBody>
+                    <a:bodyPr wrap="square"/>
+                    <a:lstStyle/>
+                    <a:p>
+                      <a:r>
+                        <a:rPr sz="850" b="0">
+                          <a:solidFill>
+                            <a:srgbClr val="141B2D"/>
+                          </a:solidFill>
+                          <a:latin typeface="Verdana"/>
+                        </a:rPr>
+                        <a:t>Cap the phrase leg's span at 6, not 5</a:t>
+                      </a:r>
+                    </a:p>
+                  </a:txBody>
+                  <a:tcPr marL="82296" marR="82296" marT="36576" marB="36576" anchor="ctr">
+                    <a:solidFill>
                       <a:srgbClr val="FFFFFF"/>
                     </a:solidFill>
                   </a:tcPr>
@@ -5702,7 +5882,7 @@
                           </a:solidFill>
                           <a:latin typeface="Verdana"/>
                         </a:rPr>
-                        <a:t>63% of the hidden targets sit in the catalog's top 1% by review count.</a:t>
+                        <a:t>A longer verbatim span should be strictly more specific.</a:t>
                       </a:r>
                     </a:p>
                   </a:txBody>

</xml_diff>